<commit_message>
I am working about reward
</commit_message>
<xml_diff>
--- a/week report/8.4展示.pptx
+++ b/week report/8.4展示.pptx
@@ -7,8 +7,12 @@
   <p:sldIdLst>
     <p:sldId id="263" r:id="rId2"/>
     <p:sldId id="258" r:id="rId3"/>
-    <p:sldId id="264" r:id="rId4"/>
-    <p:sldId id="262" r:id="rId5"/>
+    <p:sldId id="268" r:id="rId4"/>
+    <p:sldId id="265" r:id="rId5"/>
+    <p:sldId id="266" r:id="rId6"/>
+    <p:sldId id="264" r:id="rId7"/>
+    <p:sldId id="269" r:id="rId8"/>
+    <p:sldId id="262" r:id="rId9"/>
   </p:sldIdLst>
   <p:sldSz cx="12192000" cy="6858000"/>
   <p:notesSz cx="6858000" cy="9144000"/>
@@ -246,7 +250,7 @@
           <a:p>
             <a:fld id="{DCC080BC-FD8F-4BC7-912D-250C973482EE}" type="datetimeFigureOut">
               <a:rPr lang="zh-CN" altLang="en-US" smtClean="0"/>
-              <a:t>2021/7/23</a:t>
+              <a:t>2021/7/26</a:t>
             </a:fld>
             <a:endParaRPr lang="zh-CN" altLang="en-US"/>
           </a:p>
@@ -416,7 +420,7 @@
           <a:p>
             <a:fld id="{DCC080BC-FD8F-4BC7-912D-250C973482EE}" type="datetimeFigureOut">
               <a:rPr lang="zh-CN" altLang="en-US" smtClean="0"/>
-              <a:t>2021/7/23</a:t>
+              <a:t>2021/7/26</a:t>
             </a:fld>
             <a:endParaRPr lang="zh-CN" altLang="en-US"/>
           </a:p>
@@ -596,7 +600,7 @@
           <a:p>
             <a:fld id="{DCC080BC-FD8F-4BC7-912D-250C973482EE}" type="datetimeFigureOut">
               <a:rPr lang="zh-CN" altLang="en-US" smtClean="0"/>
-              <a:t>2021/7/23</a:t>
+              <a:t>2021/7/26</a:t>
             </a:fld>
             <a:endParaRPr lang="zh-CN" altLang="en-US"/>
           </a:p>
@@ -766,7 +770,7 @@
           <a:p>
             <a:fld id="{DCC080BC-FD8F-4BC7-912D-250C973482EE}" type="datetimeFigureOut">
               <a:rPr lang="zh-CN" altLang="en-US" smtClean="0"/>
-              <a:t>2021/7/23</a:t>
+              <a:t>2021/7/26</a:t>
             </a:fld>
             <a:endParaRPr lang="zh-CN" altLang="en-US"/>
           </a:p>
@@ -1012,7 +1016,7 @@
           <a:p>
             <a:fld id="{DCC080BC-FD8F-4BC7-912D-250C973482EE}" type="datetimeFigureOut">
               <a:rPr lang="zh-CN" altLang="en-US" smtClean="0"/>
-              <a:t>2021/7/23</a:t>
+              <a:t>2021/7/26</a:t>
             </a:fld>
             <a:endParaRPr lang="zh-CN" altLang="en-US"/>
           </a:p>
@@ -1244,7 +1248,7 @@
           <a:p>
             <a:fld id="{DCC080BC-FD8F-4BC7-912D-250C973482EE}" type="datetimeFigureOut">
               <a:rPr lang="zh-CN" altLang="en-US" smtClean="0"/>
-              <a:t>2021/7/23</a:t>
+              <a:t>2021/7/26</a:t>
             </a:fld>
             <a:endParaRPr lang="zh-CN" altLang="en-US"/>
           </a:p>
@@ -1611,7 +1615,7 @@
           <a:p>
             <a:fld id="{DCC080BC-FD8F-4BC7-912D-250C973482EE}" type="datetimeFigureOut">
               <a:rPr lang="zh-CN" altLang="en-US" smtClean="0"/>
-              <a:t>2021/7/23</a:t>
+              <a:t>2021/7/26</a:t>
             </a:fld>
             <a:endParaRPr lang="zh-CN" altLang="en-US"/>
           </a:p>
@@ -1729,7 +1733,7 @@
           <a:p>
             <a:fld id="{DCC080BC-FD8F-4BC7-912D-250C973482EE}" type="datetimeFigureOut">
               <a:rPr lang="zh-CN" altLang="en-US" smtClean="0"/>
-              <a:t>2021/7/23</a:t>
+              <a:t>2021/7/26</a:t>
             </a:fld>
             <a:endParaRPr lang="zh-CN" altLang="en-US"/>
           </a:p>
@@ -1824,7 +1828,7 @@
           <a:p>
             <a:fld id="{DCC080BC-FD8F-4BC7-912D-250C973482EE}" type="datetimeFigureOut">
               <a:rPr lang="zh-CN" altLang="en-US" smtClean="0"/>
-              <a:t>2021/7/23</a:t>
+              <a:t>2021/7/26</a:t>
             </a:fld>
             <a:endParaRPr lang="zh-CN" altLang="en-US"/>
           </a:p>
@@ -2101,7 +2105,7 @@
           <a:p>
             <a:fld id="{DCC080BC-FD8F-4BC7-912D-250C973482EE}" type="datetimeFigureOut">
               <a:rPr lang="zh-CN" altLang="en-US" smtClean="0"/>
-              <a:t>2021/7/23</a:t>
+              <a:t>2021/7/26</a:t>
             </a:fld>
             <a:endParaRPr lang="zh-CN" altLang="en-US"/>
           </a:p>
@@ -2354,7 +2358,7 @@
           <a:p>
             <a:fld id="{DCC080BC-FD8F-4BC7-912D-250C973482EE}" type="datetimeFigureOut">
               <a:rPr lang="zh-CN" altLang="en-US" smtClean="0"/>
-              <a:t>2021/7/23</a:t>
+              <a:t>2021/7/26</a:t>
             </a:fld>
             <a:endParaRPr lang="zh-CN" altLang="en-US"/>
           </a:p>
@@ -2567,7 +2571,7 @@
           <a:p>
             <a:fld id="{DCC080BC-FD8F-4BC7-912D-250C973482EE}" type="datetimeFigureOut">
               <a:rPr lang="zh-CN" altLang="en-US" smtClean="0"/>
-              <a:t>2021/7/23</a:t>
+              <a:t>2021/7/26</a:t>
             </a:fld>
             <a:endParaRPr lang="zh-CN" altLang="en-US"/>
           </a:p>
@@ -15673,7 +15677,7 @@
           <a:p>
             <a:fld id="{7E66CBCB-337D-49B6-B73D-DC76D0E029C4}" type="datetime1">
               <a:rPr lang="zh-CN" altLang="en-US" smtClean="0"/>
-              <a:t>2021/7/23</a:t>
+              <a:t>2021/7/26</a:t>
             </a:fld>
             <a:endParaRPr lang="zh-CN" altLang="en-US" dirty="0"/>
           </a:p>
@@ -15783,15 +15787,51 @@
           <a:p>
             <a:r>
               <a:rPr lang="zh-CN" altLang="en-US" dirty="0" smtClean="0"/>
-              <a:t>运用</a:t>
+              <a:t>分析了各种</a:t>
+            </a:r>
+            <a:r>
+              <a:rPr lang="en-US" altLang="zh-CN" dirty="0" smtClean="0"/>
+              <a:t>reward, </a:t>
+            </a:r>
+            <a:r>
+              <a:rPr lang="zh-CN" altLang="en-US" dirty="0" smtClean="0"/>
+              <a:t>来设计自己的</a:t>
+            </a:r>
+            <a:r>
+              <a:rPr lang="en-US" altLang="zh-CN" dirty="0" smtClean="0"/>
+              <a:t>reward</a:t>
+            </a:r>
+            <a:r>
+              <a:rPr lang="en-US" altLang="zh-CN" dirty="0" smtClean="0"/>
+              <a:t>. </a:t>
+            </a:r>
+            <a:r>
+              <a:rPr lang="zh-CN" altLang="en-US" dirty="0" smtClean="0"/>
+              <a:t>第一层 </a:t>
+            </a:r>
+            <a:r>
+              <a:rPr lang="en-US" altLang="zh-CN" dirty="0" smtClean="0"/>
+              <a:t>value NN </a:t>
+            </a:r>
+            <a:r>
+              <a:rPr lang="zh-CN" altLang="en-US" dirty="0" smtClean="0"/>
+              <a:t>预测</a:t>
+            </a:r>
+            <a:r>
+              <a:rPr lang="en-US" altLang="zh-CN" dirty="0" smtClean="0"/>
+              <a:t>,  </a:t>
+            </a:r>
+            <a:r>
+              <a:rPr lang="zh-CN" altLang="en-US" dirty="0" smtClean="0"/>
+              <a:t>应该先分别训练两个网络</a:t>
+            </a:r>
+            <a:r>
+              <a:rPr lang="en-US" altLang="zh-CN" smtClean="0"/>
+              <a:t>. </a:t>
             </a:r>
             <a:endParaRPr lang="en-US" altLang="zh-CN" dirty="0" smtClean="0"/>
           </a:p>
           <a:p>
-            <a:r>
-              <a:rPr lang="zh-CN" altLang="zh-CN" dirty="0" smtClean="0"/>
-              <a:t>保存</a:t>
-            </a:r>
             <a:endParaRPr lang="zh-CN" altLang="en-US" dirty="0"/>
           </a:p>
         </p:txBody>
@@ -15842,6 +15882,2269 @@
           <a:lstStyle/>
           <a:p>
             <a:r>
+              <a:rPr lang="en-US" altLang="zh-CN" dirty="0" smtClean="0"/>
+              <a:t>reward</a:t>
+            </a:r>
+            <a:endParaRPr lang="zh-CN" altLang="en-US" dirty="0"/>
+          </a:p>
+        </p:txBody>
+      </p:sp>
+      <p:graphicFrame>
+        <p:nvGraphicFramePr>
+          <p:cNvPr id="4" name="表格 3"/>
+          <p:cNvGraphicFramePr>
+            <a:graphicFrameLocks noGrp="1"/>
+          </p:cNvGraphicFramePr>
+          <p:nvPr>
+            <p:extLst>
+              <p:ext uri="{D42A27DB-BD31-4B8C-83A1-F6EECF244321}">
+                <p14:modId xmlns:p14="http://schemas.microsoft.com/office/powerpoint/2010/main" val="3373552246"/>
+              </p:ext>
+            </p:extLst>
+          </p:nvPr>
+        </p:nvGraphicFramePr>
+        <p:xfrm>
+          <a:off x="838200" y="1752598"/>
+          <a:ext cx="9398001" cy="4633200"/>
+        </p:xfrm>
+        <a:graphic>
+          <a:graphicData uri="http://schemas.openxmlformats.org/drawingml/2006/table">
+            <a:tbl>
+              <a:tblPr firstRow="1" bandRow="1">
+                <a:tableStyleId>{5C22544A-7EE6-4342-B048-85BDC9FD1C3A}</a:tableStyleId>
+              </a:tblPr>
+              <a:tblGrid>
+                <a:gridCol w="3132667">
+                  <a:extLst>
+                    <a:ext uri="{9D8B030D-6E8A-4147-A177-3AD203B41FA5}">
+                      <a16:colId xmlns:a16="http://schemas.microsoft.com/office/drawing/2014/main" val="2104862403"/>
+                    </a:ext>
+                  </a:extLst>
+                </a:gridCol>
+                <a:gridCol w="3132667">
+                  <a:extLst>
+                    <a:ext uri="{9D8B030D-6E8A-4147-A177-3AD203B41FA5}">
+                      <a16:colId xmlns:a16="http://schemas.microsoft.com/office/drawing/2014/main" val="3631488225"/>
+                    </a:ext>
+                  </a:extLst>
+                </a:gridCol>
+                <a:gridCol w="3132667">
+                  <a:extLst>
+                    <a:ext uri="{9D8B030D-6E8A-4147-A177-3AD203B41FA5}">
+                      <a16:colId xmlns:a16="http://schemas.microsoft.com/office/drawing/2014/main" val="1593399558"/>
+                    </a:ext>
+                  </a:extLst>
+                </a:gridCol>
+              </a:tblGrid>
+              <a:tr h="630000">
+                <a:tc>
+                  <a:txBody>
+                    <a:bodyPr/>
+                    <a:lstStyle/>
+                    <a:p>
+                      <a:endParaRPr lang="zh-CN" altLang="en-US" dirty="0"/>
+                    </a:p>
+                  </a:txBody>
+                  <a:tcPr/>
+                </a:tc>
+                <a:tc>
+                  <a:txBody>
+                    <a:bodyPr/>
+                    <a:lstStyle/>
+                    <a:p>
+                      <a:r>
+                        <a:rPr lang="zh-CN" altLang="en-US" dirty="0" smtClean="0"/>
+                        <a:t>怎么获得</a:t>
+                      </a:r>
+                      <a:endParaRPr lang="zh-CN" altLang="en-US" dirty="0"/>
+                    </a:p>
+                  </a:txBody>
+                  <a:tcPr/>
+                </a:tc>
+                <a:tc>
+                  <a:txBody>
+                    <a:bodyPr/>
+                    <a:lstStyle/>
+                    <a:p>
+                      <a:r>
+                        <a:rPr lang="zh-CN" altLang="en-US" dirty="0" smtClean="0"/>
+                        <a:t>是否可以用到我们的设计</a:t>
+                      </a:r>
+                      <a:endParaRPr lang="zh-CN" altLang="en-US" dirty="0"/>
+                    </a:p>
+                  </a:txBody>
+                  <a:tcPr/>
+                </a:tc>
+                <a:extLst>
+                  <a:ext uri="{0D108BD9-81ED-4DB2-BD59-A6C34878D82A}">
+                    <a16:rowId xmlns:a16="http://schemas.microsoft.com/office/drawing/2014/main" val="3322635084"/>
+                  </a:ext>
+                </a:extLst>
+              </a:tr>
+              <a:tr h="630000">
+                <a:tc>
+                  <a:txBody>
+                    <a:bodyPr/>
+                    <a:lstStyle/>
+                    <a:p>
+                      <a:r>
+                        <a:rPr lang="en-US" altLang="zh-CN" dirty="0" smtClean="0"/>
+                        <a:t>DL2</a:t>
+                      </a:r>
+                      <a:endParaRPr lang="zh-CN" altLang="en-US" dirty="0"/>
+                    </a:p>
+                  </a:txBody>
+                  <a:tcPr/>
+                </a:tc>
+                <a:tc>
+                  <a:txBody>
+                    <a:bodyPr/>
+                    <a:lstStyle/>
+                    <a:p>
+                      <a:r>
+                        <a:rPr lang="zh-CN" altLang="en-US" sz="1800" b="0" i="0" kern="1200" dirty="0" smtClean="0">
+                          <a:solidFill>
+                            <a:schemeClr val="dk1"/>
+                          </a:solidFill>
+                          <a:effectLst/>
+                          <a:latin typeface="+mn-lt"/>
+                          <a:ea typeface="+mn-ea"/>
+                          <a:cs typeface="+mn-cs"/>
+                        </a:rPr>
+                        <a:t>时隙 </a:t>
+                      </a:r>
+                      <a:r>
+                        <a:rPr lang="en-US" altLang="zh-CN" sz="1800" b="0" i="0" kern="1200" dirty="0" smtClean="0">
+                          <a:solidFill>
+                            <a:schemeClr val="dk1"/>
+                          </a:solidFill>
+                          <a:effectLst/>
+                          <a:latin typeface="+mn-lt"/>
+                          <a:ea typeface="+mn-ea"/>
+                          <a:cs typeface="+mn-cs"/>
+                        </a:rPr>
+                        <a:t>t </a:t>
+                      </a:r>
+                      <a:r>
+                        <a:rPr lang="zh-CN" altLang="en-US" sz="1800" b="0" i="0" kern="1200" dirty="0" smtClean="0">
+                          <a:solidFill>
+                            <a:schemeClr val="dk1"/>
+                          </a:solidFill>
+                          <a:effectLst/>
+                          <a:latin typeface="+mn-lt"/>
+                          <a:ea typeface="+mn-ea"/>
+                          <a:cs typeface="+mn-cs"/>
+                        </a:rPr>
+                        <a:t>中获取多个</a:t>
+                      </a:r>
+                      <a:r>
+                        <a:rPr lang="en-US" altLang="zh-CN" sz="1800" b="0" i="0" kern="1200" dirty="0" smtClean="0">
+                          <a:solidFill>
+                            <a:schemeClr val="dk1"/>
+                          </a:solidFill>
+                          <a:effectLst/>
+                          <a:latin typeface="+mn-lt"/>
+                          <a:ea typeface="+mn-ea"/>
+                          <a:cs typeface="+mn-cs"/>
+                        </a:rPr>
+                        <a:t>sample,</a:t>
+                      </a:r>
+                      <a:r>
+                        <a:rPr lang="zh-CN" altLang="en-US" sz="1800" b="0" i="0" kern="1200" dirty="0" smtClean="0">
+                          <a:solidFill>
+                            <a:schemeClr val="dk1"/>
+                          </a:solidFill>
+                          <a:effectLst/>
+                          <a:latin typeface="+mn-lt"/>
+                          <a:ea typeface="+mn-ea"/>
+                          <a:cs typeface="+mn-cs"/>
+                        </a:rPr>
+                        <a:t>对累计奖励执行 </a:t>
+                      </a:r>
+                      <a:r>
+                        <a:rPr lang="en-US" altLang="zh-CN" sz="1800" b="0" i="0" kern="1200" dirty="0" smtClean="0">
+                          <a:solidFill>
+                            <a:schemeClr val="dk1"/>
+                          </a:solidFill>
+                          <a:effectLst/>
+                          <a:latin typeface="+mn-lt"/>
+                          <a:ea typeface="+mn-ea"/>
+                          <a:cs typeface="+mn-cs"/>
+                        </a:rPr>
+                        <a:t>SGD </a:t>
+                      </a:r>
+                      <a:r>
+                        <a:rPr lang="zh-CN" altLang="en-US" sz="1800" b="0" i="0" kern="1200" dirty="0" smtClean="0">
+                          <a:solidFill>
+                            <a:schemeClr val="dk1"/>
+                          </a:solidFill>
+                          <a:effectLst/>
+                          <a:latin typeface="+mn-lt"/>
+                          <a:ea typeface="+mn-ea"/>
+                          <a:cs typeface="+mn-cs"/>
+                        </a:rPr>
+                        <a:t>来更新策略网络的参数 </a:t>
+                      </a:r>
+                      <a:endParaRPr lang="zh-CN" altLang="en-US" dirty="0"/>
+                    </a:p>
+                  </a:txBody>
+                  <a:tcPr/>
+                </a:tc>
+                <a:tc>
+                  <a:txBody>
+                    <a:bodyPr/>
+                    <a:lstStyle/>
+                    <a:p>
+                      <a:endParaRPr lang="zh-CN" altLang="en-US" dirty="0"/>
+                    </a:p>
+                  </a:txBody>
+                  <a:tcPr/>
+                </a:tc>
+                <a:extLst>
+                  <a:ext uri="{0D108BD9-81ED-4DB2-BD59-A6C34878D82A}">
+                    <a16:rowId xmlns:a16="http://schemas.microsoft.com/office/drawing/2014/main" val="4110064030"/>
+                  </a:ext>
+                </a:extLst>
+              </a:tr>
+              <a:tr h="630000">
+                <a:tc>
+                  <a:txBody>
+                    <a:bodyPr/>
+                    <a:lstStyle/>
+                    <a:p>
+                      <a:r>
+                        <a:rPr lang="en-US" altLang="zh-CN" dirty="0" smtClean="0"/>
+                        <a:t>Harmony</a:t>
+                      </a:r>
+                      <a:endParaRPr lang="zh-CN" altLang="en-US" dirty="0"/>
+                    </a:p>
+                  </a:txBody>
+                  <a:tcPr/>
+                </a:tc>
+                <a:tc>
+                  <a:txBody>
+                    <a:bodyPr/>
+                    <a:lstStyle/>
+                    <a:p>
+                      <a:r>
+                        <a:rPr lang="en-US" altLang="zh-CN" dirty="0" smtClean="0"/>
+                        <a:t>Value NN ,</a:t>
+                      </a:r>
+                      <a:r>
+                        <a:rPr lang="zh-CN" altLang="en-US" dirty="0" smtClean="0"/>
+                        <a:t>输入</a:t>
+                      </a:r>
+                      <a:r>
+                        <a:rPr lang="en-US" altLang="zh-CN" dirty="0" smtClean="0"/>
+                        <a:t>job</a:t>
+                      </a:r>
+                      <a:r>
+                        <a:rPr lang="zh-CN" altLang="en-US" dirty="0" smtClean="0"/>
+                        <a:t>信息和</a:t>
+                      </a:r>
+                      <a:r>
+                        <a:rPr lang="en-US" altLang="zh-CN" dirty="0" err="1" smtClean="0"/>
+                        <a:t>placment</a:t>
+                      </a:r>
+                      <a:r>
+                        <a:rPr lang="en-US" altLang="zh-CN" dirty="0" smtClean="0"/>
+                        <a:t>,</a:t>
+                      </a:r>
+                      <a:r>
+                        <a:rPr lang="zh-CN" altLang="en-US" dirty="0" smtClean="0"/>
+                        <a:t>输出预测</a:t>
+                      </a:r>
+                      <a:r>
+                        <a:rPr lang="en-US" altLang="zh-CN" dirty="0" smtClean="0"/>
+                        <a:t>reward</a:t>
+                      </a:r>
+                      <a:r>
+                        <a:rPr lang="en-US" altLang="zh-CN" baseline="0" dirty="0" smtClean="0"/>
+                        <a:t> </a:t>
+                      </a:r>
+                      <a:r>
+                        <a:rPr lang="zh-CN" altLang="en-US" baseline="0" dirty="0" smtClean="0"/>
+                        <a:t>作为</a:t>
+                      </a:r>
+                      <a:r>
+                        <a:rPr lang="en-US" altLang="zh-CN" baseline="0" dirty="0" smtClean="0"/>
+                        <a:t>label</a:t>
+                      </a:r>
+                      <a:r>
+                        <a:rPr lang="zh-CN" altLang="en-US" baseline="0" dirty="0" smtClean="0"/>
+                        <a:t>数据进入</a:t>
+                      </a:r>
+                      <a:r>
+                        <a:rPr lang="en-US" altLang="zh-CN" baseline="0" dirty="0" smtClean="0"/>
+                        <a:t>synthetic trace</a:t>
+                      </a:r>
+                      <a:endParaRPr lang="zh-CN" altLang="en-US" dirty="0"/>
+                    </a:p>
+                  </a:txBody>
+                  <a:tcPr/>
+                </a:tc>
+                <a:tc>
+                  <a:txBody>
+                    <a:bodyPr/>
+                    <a:lstStyle/>
+                    <a:p>
+                      <a:endParaRPr lang="zh-CN" altLang="en-US" dirty="0"/>
+                    </a:p>
+                  </a:txBody>
+                  <a:tcPr/>
+                </a:tc>
+                <a:extLst>
+                  <a:ext uri="{0D108BD9-81ED-4DB2-BD59-A6C34878D82A}">
+                    <a16:rowId xmlns:a16="http://schemas.microsoft.com/office/drawing/2014/main" val="487215583"/>
+                  </a:ext>
+                </a:extLst>
+              </a:tr>
+              <a:tr h="630000">
+                <a:tc>
+                  <a:txBody>
+                    <a:bodyPr/>
+                    <a:lstStyle/>
+                    <a:p>
+                      <a:r>
+                        <a:rPr lang="en-US" altLang="zh-CN" dirty="0" smtClean="0"/>
+                        <a:t>Hierarchy planner</a:t>
+                      </a:r>
+                      <a:endParaRPr lang="zh-CN" altLang="en-US" dirty="0"/>
+                    </a:p>
+                  </a:txBody>
+                  <a:tcPr/>
+                </a:tc>
+                <a:tc>
+                  <a:txBody>
+                    <a:bodyPr/>
+                    <a:lstStyle/>
+                    <a:p>
+                      <a:r>
+                        <a:rPr lang="en-US" altLang="zh-CN" dirty="0" smtClean="0"/>
+                        <a:t> reward</a:t>
+                      </a:r>
+                      <a:r>
+                        <a:rPr lang="zh-CN" altLang="en-US" dirty="0" smtClean="0"/>
+                        <a:t>就是运行速度</a:t>
+                      </a:r>
+                      <a:r>
+                        <a:rPr lang="en-US" altLang="zh-CN" dirty="0" smtClean="0"/>
+                        <a:t>, </a:t>
+                      </a:r>
+                      <a:r>
+                        <a:rPr lang="zh-CN" altLang="en-US" dirty="0" smtClean="0"/>
+                        <a:t>对两层分别求偏导</a:t>
+                      </a:r>
+                      <a:r>
+                        <a:rPr lang="en-US" altLang="zh-CN" dirty="0" smtClean="0"/>
+                        <a:t>,</a:t>
+                      </a:r>
+                      <a:endParaRPr lang="zh-CN" altLang="en-US" dirty="0"/>
+                    </a:p>
+                  </a:txBody>
+                  <a:tcPr/>
+                </a:tc>
+                <a:tc>
+                  <a:txBody>
+                    <a:bodyPr/>
+                    <a:lstStyle/>
+                    <a:p>
+                      <a:r>
+                        <a:rPr lang="zh-CN" altLang="en-US" dirty="0" smtClean="0"/>
+                        <a:t>可以用</a:t>
+                      </a:r>
+                      <a:endParaRPr lang="zh-CN" altLang="en-US" dirty="0"/>
+                    </a:p>
+                  </a:txBody>
+                  <a:tcPr/>
+                </a:tc>
+                <a:extLst>
+                  <a:ext uri="{0D108BD9-81ED-4DB2-BD59-A6C34878D82A}">
+                    <a16:rowId xmlns:a16="http://schemas.microsoft.com/office/drawing/2014/main" val="639321669"/>
+                  </a:ext>
+                </a:extLst>
+              </a:tr>
+              <a:tr h="630000">
+                <a:tc>
+                  <a:txBody>
+                    <a:bodyPr/>
+                    <a:lstStyle/>
+                    <a:p>
+                      <a:r>
+                        <a:rPr lang="en-US" altLang="zh-CN" dirty="0" smtClean="0"/>
+                        <a:t>H-DQN </a:t>
+                      </a:r>
+                      <a:endParaRPr lang="zh-CN" altLang="en-US" dirty="0"/>
+                    </a:p>
+                  </a:txBody>
+                  <a:tcPr/>
+                </a:tc>
+                <a:tc>
+                  <a:txBody>
+                    <a:bodyPr/>
+                    <a:lstStyle/>
+                    <a:p>
+                      <a:r>
+                        <a:rPr lang="zh-CN" altLang="en-US" dirty="0" smtClean="0"/>
+                        <a:t>内部奖励</a:t>
+                      </a:r>
+                      <a:r>
+                        <a:rPr lang="en-US" altLang="zh-CN" dirty="0" smtClean="0"/>
+                        <a:t>, </a:t>
+                      </a:r>
+                      <a:r>
+                        <a:rPr lang="zh-CN" altLang="en-US" dirty="0" smtClean="0"/>
+                        <a:t>外部奖励</a:t>
+                      </a:r>
+                      <a:endParaRPr lang="zh-CN" altLang="en-US" dirty="0"/>
+                    </a:p>
+                  </a:txBody>
+                  <a:tcPr/>
+                </a:tc>
+                <a:tc>
+                  <a:txBody>
+                    <a:bodyPr/>
+                    <a:lstStyle/>
+                    <a:p>
+                      <a:r>
+                        <a:rPr lang="zh-CN" altLang="en-US" dirty="0" smtClean="0"/>
+                        <a:t>我们不是内外</a:t>
+                      </a:r>
+                      <a:r>
+                        <a:rPr lang="en-US" altLang="zh-CN" dirty="0" smtClean="0"/>
+                        <a:t>, </a:t>
+                      </a:r>
+                      <a:r>
+                        <a:rPr lang="zh-CN" altLang="en-US" dirty="0" smtClean="0"/>
+                        <a:t>是两层</a:t>
+                      </a:r>
+                      <a:r>
+                        <a:rPr lang="en-US" altLang="zh-CN" dirty="0" smtClean="0"/>
+                        <a:t>.</a:t>
+                      </a:r>
+                      <a:r>
+                        <a:rPr lang="en-US" altLang="zh-CN" baseline="0" dirty="0" smtClean="0"/>
+                        <a:t>  </a:t>
+                      </a:r>
+                      <a:endParaRPr lang="zh-CN" altLang="en-US" dirty="0"/>
+                    </a:p>
+                  </a:txBody>
+                  <a:tcPr/>
+                </a:tc>
+                <a:extLst>
+                  <a:ext uri="{0D108BD9-81ED-4DB2-BD59-A6C34878D82A}">
+                    <a16:rowId xmlns:a16="http://schemas.microsoft.com/office/drawing/2014/main" val="1854592450"/>
+                  </a:ext>
+                </a:extLst>
+              </a:tr>
+              <a:tr h="630000">
+                <a:tc>
+                  <a:txBody>
+                    <a:bodyPr/>
+                    <a:lstStyle/>
+                    <a:p>
+                      <a:endParaRPr lang="zh-CN" altLang="en-US"/>
+                    </a:p>
+                  </a:txBody>
+                  <a:tcPr/>
+                </a:tc>
+                <a:tc>
+                  <a:txBody>
+                    <a:bodyPr/>
+                    <a:lstStyle/>
+                    <a:p>
+                      <a:endParaRPr lang="zh-CN" altLang="en-US" dirty="0"/>
+                    </a:p>
+                  </a:txBody>
+                  <a:tcPr/>
+                </a:tc>
+                <a:tc>
+                  <a:txBody>
+                    <a:bodyPr/>
+                    <a:lstStyle/>
+                    <a:p>
+                      <a:endParaRPr lang="zh-CN" altLang="en-US" dirty="0"/>
+                    </a:p>
+                  </a:txBody>
+                  <a:tcPr/>
+                </a:tc>
+                <a:extLst>
+                  <a:ext uri="{0D108BD9-81ED-4DB2-BD59-A6C34878D82A}">
+                    <a16:rowId xmlns:a16="http://schemas.microsoft.com/office/drawing/2014/main" val="2333845445"/>
+                  </a:ext>
+                </a:extLst>
+              </a:tr>
+            </a:tbl>
+          </a:graphicData>
+        </a:graphic>
+      </p:graphicFrame>
+    </p:spTree>
+    <p:extLst>
+      <p:ext uri="{BB962C8B-B14F-4D97-AF65-F5344CB8AC3E}">
+        <p14:creationId xmlns:p14="http://schemas.microsoft.com/office/powerpoint/2010/main" val="3115143314"/>
+      </p:ext>
+    </p:extLst>
+  </p:cSld>
+  <p:clrMapOvr>
+    <a:masterClrMapping/>
+  </p:clrMapOvr>
+</p:sld>
+</file>
+
+<file path=ppt/slides/slide4.xml><?xml version="1.0" encoding="utf-8"?>
+<p:sld xmlns:a="http://schemas.openxmlformats.org/drawingml/2006/main" xmlns:r="http://schemas.openxmlformats.org/officeDocument/2006/relationships" xmlns:p="http://schemas.openxmlformats.org/presentationml/2006/main">
+  <p:cSld>
+    <p:spTree>
+      <p:nvGrpSpPr>
+        <p:cNvPr id="1" name=""/>
+        <p:cNvGrpSpPr/>
+        <p:nvPr/>
+      </p:nvGrpSpPr>
+      <p:grpSpPr>
+        <a:xfrm>
+          <a:off x="0" y="0"/>
+          <a:ext cx="0" cy="0"/>
+          <a:chOff x="0" y="0"/>
+          <a:chExt cx="0" cy="0"/>
+        </a:xfrm>
+      </p:grpSpPr>
+      <p:sp>
+        <p:nvSpPr>
+          <p:cNvPr id="2" name="标题 1"/>
+          <p:cNvSpPr>
+            <a:spLocks noGrp="1"/>
+          </p:cNvSpPr>
+          <p:nvPr>
+            <p:ph type="title"/>
+          </p:nvPr>
+        </p:nvSpPr>
+        <p:spPr/>
+        <p:txBody>
+          <a:bodyPr/>
+          <a:lstStyle/>
+          <a:p>
+            <a:r>
+              <a:rPr lang="en-US" altLang="zh-CN" dirty="0" smtClean="0"/>
+              <a:t>idea1</a:t>
+            </a:r>
+            <a:endParaRPr lang="zh-CN" altLang="en-US" dirty="0"/>
+          </a:p>
+        </p:txBody>
+      </p:sp>
+      <p:sp>
+        <p:nvSpPr>
+          <p:cNvPr id="4" name="内容占位符 3"/>
+          <p:cNvSpPr>
+            <a:spLocks noGrp="1"/>
+          </p:cNvSpPr>
+          <p:nvPr>
+            <p:ph idx="1"/>
+          </p:nvPr>
+        </p:nvSpPr>
+        <p:spPr/>
+        <p:txBody>
+          <a:bodyPr/>
+          <a:lstStyle/>
+          <a:p>
+            <a:r>
+              <a:rPr lang="zh-CN" altLang="en-US" dirty="0" smtClean="0"/>
+              <a:t>输入 </a:t>
+            </a:r>
+            <a:r>
+              <a:rPr lang="en-US" altLang="zh-CN" dirty="0" smtClean="0"/>
+              <a:t>job type, </a:t>
+            </a:r>
+            <a:r>
+              <a:rPr lang="zh-CN" altLang="en-US" dirty="0" smtClean="0"/>
+              <a:t>已经运行的时间</a:t>
+            </a:r>
+            <a:r>
+              <a:rPr lang="en-US" altLang="zh-CN" dirty="0" smtClean="0"/>
+              <a:t>, </a:t>
+            </a:r>
+            <a:r>
+              <a:rPr lang="zh-CN" altLang="en-US" dirty="0" smtClean="0"/>
+              <a:t>剩余</a:t>
+            </a:r>
+            <a:r>
+              <a:rPr lang="en-US" altLang="zh-CN" dirty="0" smtClean="0"/>
+              <a:t>epoch, </a:t>
+            </a:r>
+            <a:r>
+              <a:rPr lang="zh-CN" altLang="en-US" dirty="0" smtClean="0"/>
+              <a:t>主导资源</a:t>
+            </a:r>
+            <a:r>
+              <a:rPr lang="en-US" altLang="zh-CN" dirty="0" smtClean="0"/>
+              <a:t>,job</a:t>
+            </a:r>
+            <a:r>
+              <a:rPr lang="zh-CN" altLang="en-US" dirty="0" smtClean="0"/>
+              <a:t>目前的</a:t>
+            </a:r>
+            <a:r>
+              <a:rPr lang="en-US" altLang="zh-CN" dirty="0" smtClean="0"/>
+              <a:t>worker</a:t>
+            </a:r>
+            <a:r>
+              <a:rPr lang="zh-CN" altLang="en-US" dirty="0" smtClean="0"/>
+              <a:t>和</a:t>
+            </a:r>
+            <a:r>
+              <a:rPr lang="en-US" altLang="zh-CN" dirty="0" smtClean="0"/>
+              <a:t>PS</a:t>
+            </a:r>
+          </a:p>
+          <a:p>
+            <a:r>
+              <a:rPr lang="zh-CN" altLang="en-US" dirty="0"/>
+              <a:t>第</a:t>
+            </a:r>
+            <a:r>
+              <a:rPr lang="zh-CN" altLang="en-US" dirty="0" smtClean="0"/>
+              <a:t>一级分配资源</a:t>
+            </a:r>
+            <a:r>
+              <a:rPr lang="en-US" altLang="zh-CN" dirty="0" smtClean="0"/>
+              <a:t>, </a:t>
+            </a:r>
+          </a:p>
+          <a:p>
+            <a:r>
+              <a:rPr lang="zh-CN" altLang="en-US" dirty="0"/>
+              <a:t>第二</a:t>
+            </a:r>
+            <a:r>
+              <a:rPr lang="zh-CN" altLang="en-US" dirty="0" smtClean="0"/>
+              <a:t>级 额外</a:t>
+            </a:r>
+            <a:r>
+              <a:rPr lang="en-US" altLang="zh-CN" dirty="0" smtClean="0"/>
+              <a:t>input</a:t>
+            </a:r>
+            <a:r>
+              <a:rPr lang="zh-CN" altLang="en-US" dirty="0" smtClean="0"/>
+              <a:t>服务器可用资源</a:t>
+            </a:r>
+            <a:r>
+              <a:rPr lang="en-US" altLang="zh-CN" dirty="0" smtClean="0"/>
+              <a:t>,</a:t>
+            </a:r>
+            <a:r>
+              <a:rPr lang="zh-CN" altLang="en-US" dirty="0" smtClean="0"/>
+              <a:t>当前的</a:t>
+            </a:r>
+            <a:r>
+              <a:rPr lang="en-US" altLang="zh-CN" dirty="0" smtClean="0"/>
+              <a:t>placement.</a:t>
+            </a:r>
+          </a:p>
+          <a:p>
+            <a:r>
+              <a:rPr lang="zh-CN" altLang="en-US" dirty="0" smtClean="0"/>
+              <a:t>最终输出分配的资源和</a:t>
+            </a:r>
+            <a:r>
+              <a:rPr lang="en-US" altLang="zh-CN" dirty="0" smtClean="0"/>
+              <a:t>placement.</a:t>
+            </a:r>
+          </a:p>
+          <a:p>
+            <a:r>
+              <a:rPr lang="en-US" altLang="zh-CN" dirty="0" smtClean="0"/>
+              <a:t>Reward: </a:t>
+            </a:r>
+            <a:r>
+              <a:rPr lang="zh-CN" altLang="en-US" dirty="0"/>
+              <a:t> </a:t>
+            </a:r>
+            <a:r>
+              <a:rPr lang="zh-CN" altLang="en-US" dirty="0" smtClean="0"/>
+              <a:t>计算</a:t>
+            </a:r>
+            <a:r>
+              <a:rPr lang="en-US" altLang="zh-CN" dirty="0" smtClean="0"/>
+              <a:t>reward</a:t>
+            </a:r>
+            <a:r>
+              <a:rPr lang="zh-CN" altLang="en-US" dirty="0" smtClean="0"/>
+              <a:t>给第一级和第二级用</a:t>
+            </a:r>
+            <a:r>
+              <a:rPr lang="en-US" altLang="zh-CN" dirty="0" smtClean="0"/>
+              <a:t>.</a:t>
+            </a:r>
+          </a:p>
+          <a:p>
+            <a:r>
+              <a:rPr lang="zh-CN" altLang="en-US" dirty="0" smtClean="0"/>
+              <a:t>图见下页</a:t>
+            </a:r>
+            <a:r>
+              <a:rPr lang="en-US" altLang="zh-CN" dirty="0" smtClean="0"/>
+              <a:t>. </a:t>
+            </a:r>
+            <a:r>
+              <a:rPr lang="zh-CN" altLang="en-US" dirty="0" smtClean="0"/>
+              <a:t>输入有的来自集群</a:t>
+            </a:r>
+            <a:r>
+              <a:rPr lang="en-US" altLang="zh-CN" dirty="0" err="1" smtClean="0"/>
+              <a:t>api</a:t>
+            </a:r>
+            <a:r>
+              <a:rPr lang="zh-CN" altLang="en-US" dirty="0" smtClean="0"/>
+              <a:t>有的来自</a:t>
+            </a:r>
+            <a:r>
+              <a:rPr lang="en-US" altLang="zh-CN" dirty="0" smtClean="0"/>
+              <a:t>job owner. Domain resources, job type, </a:t>
+            </a:r>
+            <a:r>
+              <a:rPr lang="en-US" altLang="zh-CN" dirty="0" err="1"/>
+              <a:t>Remaing</a:t>
+            </a:r>
+            <a:r>
+              <a:rPr lang="en-US" altLang="zh-CN" dirty="0"/>
+              <a:t> </a:t>
+            </a:r>
+            <a:r>
+              <a:rPr lang="en-US" altLang="zh-CN" dirty="0" smtClean="0"/>
+              <a:t>epoch, </a:t>
+            </a:r>
+            <a:r>
+              <a:rPr lang="zh-CN" altLang="en-US" dirty="0" smtClean="0"/>
+              <a:t>不知道怎么来的</a:t>
+            </a:r>
+            <a:endParaRPr lang="en-US" altLang="zh-CN" dirty="0" smtClean="0"/>
+          </a:p>
+        </p:txBody>
+      </p:sp>
+    </p:spTree>
+    <p:extLst>
+      <p:ext uri="{BB962C8B-B14F-4D97-AF65-F5344CB8AC3E}">
+        <p14:creationId xmlns:p14="http://schemas.microsoft.com/office/powerpoint/2010/main" val="2709092621"/>
+      </p:ext>
+    </p:extLst>
+  </p:cSld>
+  <p:clrMapOvr>
+    <a:masterClrMapping/>
+  </p:clrMapOvr>
+</p:sld>
+</file>
+
+<file path=ppt/slides/slide5.xml><?xml version="1.0" encoding="utf-8"?>
+<p:sld xmlns:a="http://schemas.openxmlformats.org/drawingml/2006/main" xmlns:r="http://schemas.openxmlformats.org/officeDocument/2006/relationships" xmlns:p="http://schemas.openxmlformats.org/presentationml/2006/main">
+  <p:cSld>
+    <p:spTree>
+      <p:nvGrpSpPr>
+        <p:cNvPr id="1" name=""/>
+        <p:cNvGrpSpPr/>
+        <p:nvPr/>
+      </p:nvGrpSpPr>
+      <p:grpSpPr>
+        <a:xfrm>
+          <a:off x="0" y="0"/>
+          <a:ext cx="0" cy="0"/>
+          <a:chOff x="0" y="0"/>
+          <a:chExt cx="0" cy="0"/>
+        </a:xfrm>
+      </p:grpSpPr>
+      <p:sp>
+        <p:nvSpPr>
+          <p:cNvPr id="69" name="圆角矩形 68"/>
+          <p:cNvSpPr/>
+          <p:nvPr/>
+        </p:nvSpPr>
+        <p:spPr>
+          <a:xfrm>
+            <a:off x="638931" y="1439333"/>
+            <a:ext cx="4754537" cy="3468838"/>
+          </a:xfrm>
+          <a:prstGeom prst="roundRect">
+            <a:avLst/>
+          </a:prstGeom>
+          <a:solidFill>
+            <a:schemeClr val="bg1"/>
+          </a:solidFill>
+          <a:ln>
+            <a:prstDash val="sysDash"/>
+          </a:ln>
+        </p:spPr>
+        <p:style>
+          <a:lnRef idx="2">
+            <a:schemeClr val="accent1">
+              <a:shade val="50000"/>
+            </a:schemeClr>
+          </a:lnRef>
+          <a:fillRef idx="1">
+            <a:schemeClr val="accent1"/>
+          </a:fillRef>
+          <a:effectRef idx="0">
+            <a:schemeClr val="accent1"/>
+          </a:effectRef>
+          <a:fontRef idx="minor">
+            <a:schemeClr val="lt1"/>
+          </a:fontRef>
+        </p:style>
+        <p:txBody>
+          <a:bodyPr rtlCol="0" anchor="ctr"/>
+          <a:lstStyle/>
+          <a:p>
+            <a:pPr algn="ctr"/>
+            <a:endParaRPr lang="zh-CN" altLang="en-US"/>
+          </a:p>
+        </p:txBody>
+      </p:sp>
+      <p:sp>
+        <p:nvSpPr>
+          <p:cNvPr id="28" name="矩形 27"/>
+          <p:cNvSpPr/>
+          <p:nvPr/>
+        </p:nvSpPr>
+        <p:spPr>
+          <a:xfrm>
+            <a:off x="3298048" y="2640434"/>
+            <a:ext cx="1280667" cy="749285"/>
+          </a:xfrm>
+          <a:prstGeom prst="rect">
+            <a:avLst/>
+          </a:prstGeom>
+          <a:solidFill>
+            <a:schemeClr val="bg1"/>
+          </a:solidFill>
+        </p:spPr>
+        <p:style>
+          <a:lnRef idx="2">
+            <a:schemeClr val="accent1">
+              <a:shade val="50000"/>
+            </a:schemeClr>
+          </a:lnRef>
+          <a:fillRef idx="1">
+            <a:schemeClr val="accent1"/>
+          </a:fillRef>
+          <a:effectRef idx="0">
+            <a:schemeClr val="accent1"/>
+          </a:effectRef>
+          <a:fontRef idx="minor">
+            <a:schemeClr val="lt1"/>
+          </a:fontRef>
+        </p:style>
+        <p:txBody>
+          <a:bodyPr rtlCol="0" anchor="ctr"/>
+          <a:lstStyle/>
+          <a:p>
+            <a:pPr algn="ctr"/>
+            <a:endParaRPr lang="zh-CN" altLang="en-US" dirty="0"/>
+          </a:p>
+        </p:txBody>
+      </p:sp>
+      <p:sp>
+        <p:nvSpPr>
+          <p:cNvPr id="6" name="文本框 5"/>
+          <p:cNvSpPr txBox="1"/>
+          <p:nvPr/>
+        </p:nvSpPr>
+        <p:spPr>
+          <a:xfrm>
+            <a:off x="705651" y="1644285"/>
+            <a:ext cx="1219487" cy="369332"/>
+          </a:xfrm>
+          <a:prstGeom prst="rect">
+            <a:avLst/>
+          </a:prstGeom>
+          <a:noFill/>
+        </p:spPr>
+        <p:txBody>
+          <a:bodyPr wrap="square" rtlCol="0">
+            <a:spAutoFit/>
+          </a:bodyPr>
+          <a:lstStyle/>
+          <a:p>
+            <a:r>
+              <a:rPr lang="en-US" altLang="zh-CN" dirty="0" smtClean="0"/>
+              <a:t>Job type</a:t>
+            </a:r>
+            <a:endParaRPr lang="zh-CN" altLang="en-US" dirty="0"/>
+          </a:p>
+        </p:txBody>
+      </p:sp>
+      <p:sp>
+        <p:nvSpPr>
+          <p:cNvPr id="7" name="文本框 6"/>
+          <p:cNvSpPr txBox="1"/>
+          <p:nvPr/>
+        </p:nvSpPr>
+        <p:spPr>
+          <a:xfrm>
+            <a:off x="638931" y="2967857"/>
+            <a:ext cx="1773621" cy="369332"/>
+          </a:xfrm>
+          <a:prstGeom prst="rect">
+            <a:avLst/>
+          </a:prstGeom>
+          <a:noFill/>
+        </p:spPr>
+        <p:txBody>
+          <a:bodyPr wrap="square" rtlCol="0">
+            <a:spAutoFit/>
+          </a:bodyPr>
+          <a:lstStyle/>
+          <a:p>
+            <a:r>
+              <a:rPr lang="en-US" altLang="zh-CN" dirty="0" err="1" smtClean="0"/>
+              <a:t>Remaing</a:t>
+            </a:r>
+            <a:r>
+              <a:rPr lang="en-US" altLang="zh-CN" dirty="0" smtClean="0"/>
+              <a:t> epoch</a:t>
+            </a:r>
+            <a:endParaRPr lang="zh-CN" altLang="en-US" dirty="0"/>
+          </a:p>
+        </p:txBody>
+      </p:sp>
+      <p:sp>
+        <p:nvSpPr>
+          <p:cNvPr id="13" name="文本框 12"/>
+          <p:cNvSpPr txBox="1"/>
+          <p:nvPr/>
+        </p:nvSpPr>
+        <p:spPr>
+          <a:xfrm>
+            <a:off x="705651" y="2279530"/>
+            <a:ext cx="1219487" cy="369332"/>
+          </a:xfrm>
+          <a:prstGeom prst="rect">
+            <a:avLst/>
+          </a:prstGeom>
+          <a:noFill/>
+        </p:spPr>
+        <p:txBody>
+          <a:bodyPr wrap="square" rtlCol="0">
+            <a:spAutoFit/>
+          </a:bodyPr>
+          <a:lstStyle/>
+          <a:p>
+            <a:r>
+              <a:rPr lang="en-US" altLang="zh-CN" dirty="0" smtClean="0"/>
+              <a:t>Run time</a:t>
+            </a:r>
+            <a:endParaRPr lang="zh-CN" altLang="en-US" dirty="0"/>
+          </a:p>
+        </p:txBody>
+      </p:sp>
+      <p:sp>
+        <p:nvSpPr>
+          <p:cNvPr id="14" name="文本框 13"/>
+          <p:cNvSpPr txBox="1"/>
+          <p:nvPr/>
+        </p:nvSpPr>
+        <p:spPr>
+          <a:xfrm>
+            <a:off x="572215" y="3560695"/>
+            <a:ext cx="1907055" cy="369332"/>
+          </a:xfrm>
+          <a:prstGeom prst="rect">
+            <a:avLst/>
+          </a:prstGeom>
+          <a:noFill/>
+        </p:spPr>
+        <p:txBody>
+          <a:bodyPr wrap="square" rtlCol="0">
+            <a:spAutoFit/>
+          </a:bodyPr>
+          <a:lstStyle/>
+          <a:p>
+            <a:r>
+              <a:rPr lang="en-US" altLang="zh-CN" dirty="0" smtClean="0"/>
+              <a:t>Domain resource</a:t>
+            </a:r>
+            <a:endParaRPr lang="zh-CN" altLang="en-US" dirty="0"/>
+          </a:p>
+        </p:txBody>
+      </p:sp>
+      <p:sp>
+        <p:nvSpPr>
+          <p:cNvPr id="15" name="文本框 14"/>
+          <p:cNvSpPr txBox="1"/>
+          <p:nvPr/>
+        </p:nvSpPr>
+        <p:spPr>
+          <a:xfrm>
+            <a:off x="705650" y="4147430"/>
+            <a:ext cx="1773621" cy="369332"/>
+          </a:xfrm>
+          <a:prstGeom prst="rect">
+            <a:avLst/>
+          </a:prstGeom>
+          <a:noFill/>
+        </p:spPr>
+        <p:txBody>
+          <a:bodyPr wrap="square" rtlCol="0">
+            <a:spAutoFit/>
+          </a:bodyPr>
+          <a:lstStyle/>
+          <a:p>
+            <a:r>
+              <a:rPr lang="en-US" altLang="zh-CN" dirty="0" smtClean="0"/>
+              <a:t>Job’s worker/PS</a:t>
+            </a:r>
+            <a:endParaRPr lang="zh-CN" altLang="en-US" dirty="0"/>
+          </a:p>
+        </p:txBody>
+      </p:sp>
+      <p:cxnSp>
+        <p:nvCxnSpPr>
+          <p:cNvPr id="18" name="直接箭头连接符 17"/>
+          <p:cNvCxnSpPr>
+            <a:stCxn id="6" idx="3"/>
+            <a:endCxn id="28" idx="1"/>
+          </p:cNvCxnSpPr>
+          <p:nvPr/>
+        </p:nvCxnSpPr>
+        <p:spPr>
+          <a:xfrm>
+            <a:off x="1925138" y="1828951"/>
+            <a:ext cx="1372910" cy="1186126"/>
+          </a:xfrm>
+          <a:prstGeom prst="straightConnector1">
+            <a:avLst/>
+          </a:prstGeom>
+          <a:ln>
+            <a:tailEnd type="triangle"/>
+          </a:ln>
+        </p:spPr>
+        <p:style>
+          <a:lnRef idx="1">
+            <a:schemeClr val="accent1"/>
+          </a:lnRef>
+          <a:fillRef idx="0">
+            <a:schemeClr val="accent1"/>
+          </a:fillRef>
+          <a:effectRef idx="0">
+            <a:schemeClr val="accent1"/>
+          </a:effectRef>
+          <a:fontRef idx="minor">
+            <a:schemeClr val="tx1"/>
+          </a:fontRef>
+        </p:style>
+      </p:cxnSp>
+      <p:cxnSp>
+        <p:nvCxnSpPr>
+          <p:cNvPr id="20" name="直接箭头连接符 19"/>
+          <p:cNvCxnSpPr>
+            <a:stCxn id="13" idx="3"/>
+            <a:endCxn id="28" idx="1"/>
+          </p:cNvCxnSpPr>
+          <p:nvPr/>
+        </p:nvCxnSpPr>
+        <p:spPr>
+          <a:xfrm>
+            <a:off x="1925138" y="2464196"/>
+            <a:ext cx="1372910" cy="550881"/>
+          </a:xfrm>
+          <a:prstGeom prst="straightConnector1">
+            <a:avLst/>
+          </a:prstGeom>
+          <a:ln>
+            <a:tailEnd type="triangle"/>
+          </a:ln>
+        </p:spPr>
+        <p:style>
+          <a:lnRef idx="1">
+            <a:schemeClr val="accent1"/>
+          </a:lnRef>
+          <a:fillRef idx="0">
+            <a:schemeClr val="accent1"/>
+          </a:fillRef>
+          <a:effectRef idx="0">
+            <a:schemeClr val="accent1"/>
+          </a:effectRef>
+          <a:fontRef idx="minor">
+            <a:schemeClr val="tx1"/>
+          </a:fontRef>
+        </p:style>
+      </p:cxnSp>
+      <p:cxnSp>
+        <p:nvCxnSpPr>
+          <p:cNvPr id="21" name="直接箭头连接符 20"/>
+          <p:cNvCxnSpPr>
+            <a:stCxn id="7" idx="3"/>
+            <a:endCxn id="28" idx="1"/>
+          </p:cNvCxnSpPr>
+          <p:nvPr/>
+        </p:nvCxnSpPr>
+        <p:spPr>
+          <a:xfrm flipV="1">
+            <a:off x="2412552" y="3015077"/>
+            <a:ext cx="885496" cy="137446"/>
+          </a:xfrm>
+          <a:prstGeom prst="straightConnector1">
+            <a:avLst/>
+          </a:prstGeom>
+          <a:ln>
+            <a:tailEnd type="triangle"/>
+          </a:ln>
+        </p:spPr>
+        <p:style>
+          <a:lnRef idx="1">
+            <a:schemeClr val="accent1"/>
+          </a:lnRef>
+          <a:fillRef idx="0">
+            <a:schemeClr val="accent1"/>
+          </a:fillRef>
+          <a:effectRef idx="0">
+            <a:schemeClr val="accent1"/>
+          </a:effectRef>
+          <a:fontRef idx="minor">
+            <a:schemeClr val="tx1"/>
+          </a:fontRef>
+        </p:style>
+      </p:cxnSp>
+      <p:cxnSp>
+        <p:nvCxnSpPr>
+          <p:cNvPr id="22" name="直接箭头连接符 21"/>
+          <p:cNvCxnSpPr>
+            <a:stCxn id="14" idx="3"/>
+            <a:endCxn id="28" idx="1"/>
+          </p:cNvCxnSpPr>
+          <p:nvPr/>
+        </p:nvCxnSpPr>
+        <p:spPr>
+          <a:xfrm flipV="1">
+            <a:off x="2479270" y="3015077"/>
+            <a:ext cx="818778" cy="730284"/>
+          </a:xfrm>
+          <a:prstGeom prst="straightConnector1">
+            <a:avLst/>
+          </a:prstGeom>
+          <a:ln>
+            <a:tailEnd type="triangle"/>
+          </a:ln>
+        </p:spPr>
+        <p:style>
+          <a:lnRef idx="1">
+            <a:schemeClr val="accent1"/>
+          </a:lnRef>
+          <a:fillRef idx="0">
+            <a:schemeClr val="accent1"/>
+          </a:fillRef>
+          <a:effectRef idx="0">
+            <a:schemeClr val="accent1"/>
+          </a:effectRef>
+          <a:fontRef idx="minor">
+            <a:schemeClr val="tx1"/>
+          </a:fontRef>
+        </p:style>
+      </p:cxnSp>
+      <p:cxnSp>
+        <p:nvCxnSpPr>
+          <p:cNvPr id="23" name="直接箭头连接符 22"/>
+          <p:cNvCxnSpPr>
+            <a:stCxn id="15" idx="3"/>
+            <a:endCxn id="28" idx="1"/>
+          </p:cNvCxnSpPr>
+          <p:nvPr/>
+        </p:nvCxnSpPr>
+        <p:spPr>
+          <a:xfrm flipV="1">
+            <a:off x="2479271" y="3015077"/>
+            <a:ext cx="818777" cy="1317019"/>
+          </a:xfrm>
+          <a:prstGeom prst="straightConnector1">
+            <a:avLst/>
+          </a:prstGeom>
+          <a:ln>
+            <a:tailEnd type="triangle"/>
+          </a:ln>
+        </p:spPr>
+        <p:style>
+          <a:lnRef idx="1">
+            <a:schemeClr val="accent1"/>
+          </a:lnRef>
+          <a:fillRef idx="0">
+            <a:schemeClr val="accent1"/>
+          </a:fillRef>
+          <a:effectRef idx="0">
+            <a:schemeClr val="accent1"/>
+          </a:effectRef>
+          <a:fontRef idx="minor">
+            <a:schemeClr val="tx1"/>
+          </a:fontRef>
+        </p:style>
+      </p:cxnSp>
+      <p:sp>
+        <p:nvSpPr>
+          <p:cNvPr id="29" name="文本框 28"/>
+          <p:cNvSpPr txBox="1"/>
+          <p:nvPr/>
+        </p:nvSpPr>
+        <p:spPr>
+          <a:xfrm>
+            <a:off x="3421026" y="2808230"/>
+            <a:ext cx="1157689" cy="369332"/>
+          </a:xfrm>
+          <a:prstGeom prst="rect">
+            <a:avLst/>
+          </a:prstGeom>
+          <a:noFill/>
+        </p:spPr>
+        <p:txBody>
+          <a:bodyPr wrap="none" rtlCol="0">
+            <a:spAutoFit/>
+          </a:bodyPr>
+          <a:lstStyle/>
+          <a:p>
+            <a:r>
+              <a:rPr lang="en-US" altLang="zh-CN" dirty="0" smtClean="0"/>
+              <a:t>Policy NN</a:t>
+            </a:r>
+            <a:endParaRPr lang="zh-CN" altLang="en-US" dirty="0"/>
+          </a:p>
+        </p:txBody>
+      </p:sp>
+      <p:sp>
+        <p:nvSpPr>
+          <p:cNvPr id="70" name="圆角矩形 69"/>
+          <p:cNvSpPr/>
+          <p:nvPr/>
+        </p:nvSpPr>
+        <p:spPr>
+          <a:xfrm>
+            <a:off x="6034494" y="1384889"/>
+            <a:ext cx="5537671" cy="3511296"/>
+          </a:xfrm>
+          <a:prstGeom prst="roundRect">
+            <a:avLst/>
+          </a:prstGeom>
+          <a:solidFill>
+            <a:schemeClr val="bg1"/>
+          </a:solidFill>
+          <a:ln>
+            <a:prstDash val="sysDash"/>
+          </a:ln>
+        </p:spPr>
+        <p:style>
+          <a:lnRef idx="2">
+            <a:schemeClr val="accent1">
+              <a:shade val="50000"/>
+            </a:schemeClr>
+          </a:lnRef>
+          <a:fillRef idx="1">
+            <a:schemeClr val="accent1"/>
+          </a:fillRef>
+          <a:effectRef idx="0">
+            <a:schemeClr val="accent1"/>
+          </a:effectRef>
+          <a:fontRef idx="minor">
+            <a:schemeClr val="lt1"/>
+          </a:fontRef>
+        </p:style>
+        <p:txBody>
+          <a:bodyPr rtlCol="0" anchor="ctr"/>
+          <a:lstStyle/>
+          <a:p>
+            <a:pPr algn="ctr"/>
+            <a:endParaRPr lang="zh-CN" altLang="en-US"/>
+          </a:p>
+        </p:txBody>
+      </p:sp>
+      <p:cxnSp>
+        <p:nvCxnSpPr>
+          <p:cNvPr id="30" name="直接箭头连接符 29"/>
+          <p:cNvCxnSpPr>
+            <a:stCxn id="28" idx="3"/>
+            <a:endCxn id="73" idx="1"/>
+          </p:cNvCxnSpPr>
+          <p:nvPr/>
+        </p:nvCxnSpPr>
+        <p:spPr>
+          <a:xfrm>
+            <a:off x="4578715" y="3015077"/>
+            <a:ext cx="1450238" cy="0"/>
+          </a:xfrm>
+          <a:prstGeom prst="straightConnector1">
+            <a:avLst/>
+          </a:prstGeom>
+          <a:ln>
+            <a:tailEnd type="triangle"/>
+          </a:ln>
+        </p:spPr>
+        <p:style>
+          <a:lnRef idx="1">
+            <a:schemeClr val="accent1"/>
+          </a:lnRef>
+          <a:fillRef idx="0">
+            <a:schemeClr val="accent1"/>
+          </a:fillRef>
+          <a:effectRef idx="0">
+            <a:schemeClr val="accent1"/>
+          </a:effectRef>
+          <a:fontRef idx="minor">
+            <a:schemeClr val="tx1"/>
+          </a:fontRef>
+        </p:style>
+      </p:cxnSp>
+      <p:cxnSp>
+        <p:nvCxnSpPr>
+          <p:cNvPr id="34" name="直接箭头连接符 33"/>
+          <p:cNvCxnSpPr>
+            <a:stCxn id="6" idx="3"/>
+            <a:endCxn id="72" idx="1"/>
+          </p:cNvCxnSpPr>
+          <p:nvPr/>
+        </p:nvCxnSpPr>
+        <p:spPr>
+          <a:xfrm>
+            <a:off x="1925138" y="1828951"/>
+            <a:ext cx="4218845" cy="0"/>
+          </a:xfrm>
+          <a:prstGeom prst="straightConnector1">
+            <a:avLst/>
+          </a:prstGeom>
+          <a:ln>
+            <a:tailEnd type="triangle"/>
+          </a:ln>
+        </p:spPr>
+        <p:style>
+          <a:lnRef idx="1">
+            <a:schemeClr val="accent1"/>
+          </a:lnRef>
+          <a:fillRef idx="0">
+            <a:schemeClr val="accent1"/>
+          </a:fillRef>
+          <a:effectRef idx="0">
+            <a:schemeClr val="accent1"/>
+          </a:effectRef>
+          <a:fontRef idx="minor">
+            <a:schemeClr val="tx1"/>
+          </a:fontRef>
+        </p:style>
+      </p:cxnSp>
+      <p:sp>
+        <p:nvSpPr>
+          <p:cNvPr id="38" name="文本框 37"/>
+          <p:cNvSpPr txBox="1"/>
+          <p:nvPr/>
+        </p:nvSpPr>
+        <p:spPr>
+          <a:xfrm>
+            <a:off x="4754108" y="2234764"/>
+            <a:ext cx="1236694" cy="646331"/>
+          </a:xfrm>
+          <a:prstGeom prst="rect">
+            <a:avLst/>
+          </a:prstGeom>
+          <a:noFill/>
+        </p:spPr>
+        <p:txBody>
+          <a:bodyPr wrap="square" rtlCol="0">
+            <a:spAutoFit/>
+          </a:bodyPr>
+          <a:lstStyle/>
+          <a:p>
+            <a:r>
+              <a:rPr lang="en-US" altLang="zh-CN" dirty="0" smtClean="0"/>
+              <a:t>Allocate worker/PS</a:t>
+            </a:r>
+            <a:endParaRPr lang="zh-CN" altLang="en-US" dirty="0"/>
+          </a:p>
+        </p:txBody>
+      </p:sp>
+      <p:sp>
+        <p:nvSpPr>
+          <p:cNvPr id="71" name="矩形 70"/>
+          <p:cNvSpPr/>
+          <p:nvPr/>
+        </p:nvSpPr>
+        <p:spPr>
+          <a:xfrm>
+            <a:off x="8070948" y="2559370"/>
+            <a:ext cx="1416991" cy="749285"/>
+          </a:xfrm>
+          <a:prstGeom prst="rect">
+            <a:avLst/>
+          </a:prstGeom>
+          <a:solidFill>
+            <a:schemeClr val="bg1"/>
+          </a:solidFill>
+        </p:spPr>
+        <p:style>
+          <a:lnRef idx="2">
+            <a:schemeClr val="accent1">
+              <a:shade val="50000"/>
+            </a:schemeClr>
+          </a:lnRef>
+          <a:fillRef idx="1">
+            <a:schemeClr val="accent1"/>
+          </a:fillRef>
+          <a:effectRef idx="0">
+            <a:schemeClr val="accent1"/>
+          </a:effectRef>
+          <a:fontRef idx="minor">
+            <a:schemeClr val="lt1"/>
+          </a:fontRef>
+        </p:style>
+        <p:txBody>
+          <a:bodyPr rtlCol="0" anchor="ctr"/>
+          <a:lstStyle/>
+          <a:p>
+            <a:pPr algn="ctr"/>
+            <a:endParaRPr lang="zh-CN" altLang="en-US" dirty="0"/>
+          </a:p>
+        </p:txBody>
+      </p:sp>
+      <p:sp>
+        <p:nvSpPr>
+          <p:cNvPr id="72" name="文本框 71"/>
+          <p:cNvSpPr txBox="1"/>
+          <p:nvPr/>
+        </p:nvSpPr>
+        <p:spPr>
+          <a:xfrm>
+            <a:off x="6143983" y="1644285"/>
+            <a:ext cx="1071383" cy="369332"/>
+          </a:xfrm>
+          <a:prstGeom prst="rect">
+            <a:avLst/>
+          </a:prstGeom>
+          <a:noFill/>
+        </p:spPr>
+        <p:txBody>
+          <a:bodyPr wrap="square" rtlCol="0">
+            <a:spAutoFit/>
+          </a:bodyPr>
+          <a:lstStyle/>
+          <a:p>
+            <a:r>
+              <a:rPr lang="en-US" altLang="zh-CN" dirty="0" smtClean="0"/>
+              <a:t>Job type</a:t>
+            </a:r>
+            <a:endParaRPr lang="zh-CN" altLang="en-US" dirty="0"/>
+          </a:p>
+        </p:txBody>
+      </p:sp>
+      <p:sp>
+        <p:nvSpPr>
+          <p:cNvPr id="73" name="文本框 72"/>
+          <p:cNvSpPr txBox="1"/>
+          <p:nvPr/>
+        </p:nvSpPr>
+        <p:spPr>
+          <a:xfrm>
+            <a:off x="6028953" y="2830411"/>
+            <a:ext cx="1286207" cy="369332"/>
+          </a:xfrm>
+          <a:prstGeom prst="rect">
+            <a:avLst/>
+          </a:prstGeom>
+          <a:noFill/>
+        </p:spPr>
+        <p:txBody>
+          <a:bodyPr wrap="square" rtlCol="0">
+            <a:spAutoFit/>
+          </a:bodyPr>
+          <a:lstStyle/>
+          <a:p>
+            <a:r>
+              <a:rPr lang="en-US" altLang="zh-CN" dirty="0" smtClean="0"/>
+              <a:t>Worker/PS</a:t>
+            </a:r>
+            <a:endParaRPr lang="zh-CN" altLang="en-US" dirty="0"/>
+          </a:p>
+        </p:txBody>
+      </p:sp>
+      <p:sp>
+        <p:nvSpPr>
+          <p:cNvPr id="74" name="文本框 73"/>
+          <p:cNvSpPr txBox="1"/>
+          <p:nvPr/>
+        </p:nvSpPr>
+        <p:spPr>
+          <a:xfrm>
+            <a:off x="6095673" y="2142084"/>
+            <a:ext cx="1219487" cy="646331"/>
+          </a:xfrm>
+          <a:prstGeom prst="rect">
+            <a:avLst/>
+          </a:prstGeom>
+          <a:noFill/>
+        </p:spPr>
+        <p:txBody>
+          <a:bodyPr wrap="square" rtlCol="0">
+            <a:spAutoFit/>
+          </a:bodyPr>
+          <a:lstStyle/>
+          <a:p>
+            <a:r>
+              <a:rPr lang="en-US" altLang="zh-CN" dirty="0" smtClean="0"/>
+              <a:t>Resource demand</a:t>
+            </a:r>
+            <a:endParaRPr lang="zh-CN" altLang="en-US" dirty="0"/>
+          </a:p>
+        </p:txBody>
+      </p:sp>
+      <p:sp>
+        <p:nvSpPr>
+          <p:cNvPr id="75" name="文本框 74"/>
+          <p:cNvSpPr txBox="1"/>
+          <p:nvPr/>
+        </p:nvSpPr>
+        <p:spPr>
+          <a:xfrm>
+            <a:off x="6129347" y="3308655"/>
+            <a:ext cx="1185813" cy="646331"/>
+          </a:xfrm>
+          <a:prstGeom prst="rect">
+            <a:avLst/>
+          </a:prstGeom>
+          <a:noFill/>
+        </p:spPr>
+        <p:txBody>
+          <a:bodyPr wrap="square" rtlCol="0">
+            <a:spAutoFit/>
+          </a:bodyPr>
+          <a:lstStyle/>
+          <a:p>
+            <a:r>
+              <a:rPr lang="en-US" altLang="zh-CN" dirty="0" smtClean="0"/>
+              <a:t>available resource</a:t>
+            </a:r>
+            <a:endParaRPr lang="zh-CN" altLang="en-US" dirty="0"/>
+          </a:p>
+        </p:txBody>
+      </p:sp>
+      <p:sp>
+        <p:nvSpPr>
+          <p:cNvPr id="76" name="文本框 75"/>
+          <p:cNvSpPr txBox="1"/>
+          <p:nvPr/>
+        </p:nvSpPr>
+        <p:spPr>
+          <a:xfrm>
+            <a:off x="6095673" y="4009984"/>
+            <a:ext cx="1219488" cy="646331"/>
+          </a:xfrm>
+          <a:prstGeom prst="rect">
+            <a:avLst/>
+          </a:prstGeom>
+          <a:noFill/>
+        </p:spPr>
+        <p:txBody>
+          <a:bodyPr wrap="square" rtlCol="0">
+            <a:spAutoFit/>
+          </a:bodyPr>
+          <a:lstStyle/>
+          <a:p>
+            <a:r>
+              <a:rPr lang="en-US" altLang="zh-CN" dirty="0" smtClean="0"/>
+              <a:t>Current placement</a:t>
+            </a:r>
+            <a:endParaRPr lang="zh-CN" altLang="en-US" dirty="0"/>
+          </a:p>
+        </p:txBody>
+      </p:sp>
+      <p:cxnSp>
+        <p:nvCxnSpPr>
+          <p:cNvPr id="77" name="直接箭头连接符 76"/>
+          <p:cNvCxnSpPr>
+            <a:stCxn id="72" idx="3"/>
+            <a:endCxn id="71" idx="1"/>
+          </p:cNvCxnSpPr>
+          <p:nvPr/>
+        </p:nvCxnSpPr>
+        <p:spPr>
+          <a:xfrm>
+            <a:off x="7215366" y="1828951"/>
+            <a:ext cx="855582" cy="1105062"/>
+          </a:xfrm>
+          <a:prstGeom prst="straightConnector1">
+            <a:avLst/>
+          </a:prstGeom>
+          <a:ln>
+            <a:tailEnd type="triangle"/>
+          </a:ln>
+        </p:spPr>
+        <p:style>
+          <a:lnRef idx="1">
+            <a:schemeClr val="accent1"/>
+          </a:lnRef>
+          <a:fillRef idx="0">
+            <a:schemeClr val="accent1"/>
+          </a:fillRef>
+          <a:effectRef idx="0">
+            <a:schemeClr val="accent1"/>
+          </a:effectRef>
+          <a:fontRef idx="minor">
+            <a:schemeClr val="tx1"/>
+          </a:fontRef>
+        </p:style>
+      </p:cxnSp>
+      <p:cxnSp>
+        <p:nvCxnSpPr>
+          <p:cNvPr id="78" name="直接箭头连接符 77"/>
+          <p:cNvCxnSpPr>
+            <a:stCxn id="74" idx="3"/>
+            <a:endCxn id="71" idx="1"/>
+          </p:cNvCxnSpPr>
+          <p:nvPr/>
+        </p:nvCxnSpPr>
+        <p:spPr>
+          <a:xfrm>
+            <a:off x="7315160" y="2465250"/>
+            <a:ext cx="755788" cy="468763"/>
+          </a:xfrm>
+          <a:prstGeom prst="straightConnector1">
+            <a:avLst/>
+          </a:prstGeom>
+          <a:ln>
+            <a:tailEnd type="triangle"/>
+          </a:ln>
+        </p:spPr>
+        <p:style>
+          <a:lnRef idx="1">
+            <a:schemeClr val="accent1"/>
+          </a:lnRef>
+          <a:fillRef idx="0">
+            <a:schemeClr val="accent1"/>
+          </a:fillRef>
+          <a:effectRef idx="0">
+            <a:schemeClr val="accent1"/>
+          </a:effectRef>
+          <a:fontRef idx="minor">
+            <a:schemeClr val="tx1"/>
+          </a:fontRef>
+        </p:style>
+      </p:cxnSp>
+      <p:cxnSp>
+        <p:nvCxnSpPr>
+          <p:cNvPr id="79" name="直接箭头连接符 78"/>
+          <p:cNvCxnSpPr>
+            <a:stCxn id="73" idx="3"/>
+            <a:endCxn id="71" idx="1"/>
+          </p:cNvCxnSpPr>
+          <p:nvPr/>
+        </p:nvCxnSpPr>
+        <p:spPr>
+          <a:xfrm flipV="1">
+            <a:off x="7315160" y="2934013"/>
+            <a:ext cx="755788" cy="81064"/>
+          </a:xfrm>
+          <a:prstGeom prst="straightConnector1">
+            <a:avLst/>
+          </a:prstGeom>
+          <a:ln>
+            <a:tailEnd type="triangle"/>
+          </a:ln>
+        </p:spPr>
+        <p:style>
+          <a:lnRef idx="1">
+            <a:schemeClr val="accent1"/>
+          </a:lnRef>
+          <a:fillRef idx="0">
+            <a:schemeClr val="accent1"/>
+          </a:fillRef>
+          <a:effectRef idx="0">
+            <a:schemeClr val="accent1"/>
+          </a:effectRef>
+          <a:fontRef idx="minor">
+            <a:schemeClr val="tx1"/>
+          </a:fontRef>
+        </p:style>
+      </p:cxnSp>
+      <p:cxnSp>
+        <p:nvCxnSpPr>
+          <p:cNvPr id="80" name="直接箭头连接符 79"/>
+          <p:cNvCxnSpPr>
+            <a:stCxn id="75" idx="3"/>
+            <a:endCxn id="71" idx="1"/>
+          </p:cNvCxnSpPr>
+          <p:nvPr/>
+        </p:nvCxnSpPr>
+        <p:spPr>
+          <a:xfrm flipV="1">
+            <a:off x="7315160" y="2934013"/>
+            <a:ext cx="755788" cy="697808"/>
+          </a:xfrm>
+          <a:prstGeom prst="straightConnector1">
+            <a:avLst/>
+          </a:prstGeom>
+          <a:ln>
+            <a:tailEnd type="triangle"/>
+          </a:ln>
+        </p:spPr>
+        <p:style>
+          <a:lnRef idx="1">
+            <a:schemeClr val="accent1"/>
+          </a:lnRef>
+          <a:fillRef idx="0">
+            <a:schemeClr val="accent1"/>
+          </a:fillRef>
+          <a:effectRef idx="0">
+            <a:schemeClr val="accent1"/>
+          </a:effectRef>
+          <a:fontRef idx="minor">
+            <a:schemeClr val="tx1"/>
+          </a:fontRef>
+        </p:style>
+      </p:cxnSp>
+      <p:cxnSp>
+        <p:nvCxnSpPr>
+          <p:cNvPr id="81" name="直接箭头连接符 80"/>
+          <p:cNvCxnSpPr>
+            <a:stCxn id="76" idx="3"/>
+            <a:endCxn id="71" idx="1"/>
+          </p:cNvCxnSpPr>
+          <p:nvPr/>
+        </p:nvCxnSpPr>
+        <p:spPr>
+          <a:xfrm flipV="1">
+            <a:off x="7315161" y="2934013"/>
+            <a:ext cx="755787" cy="1399137"/>
+          </a:xfrm>
+          <a:prstGeom prst="straightConnector1">
+            <a:avLst/>
+          </a:prstGeom>
+          <a:ln>
+            <a:tailEnd type="triangle"/>
+          </a:ln>
+        </p:spPr>
+        <p:style>
+          <a:lnRef idx="1">
+            <a:schemeClr val="accent1"/>
+          </a:lnRef>
+          <a:fillRef idx="0">
+            <a:schemeClr val="accent1"/>
+          </a:fillRef>
+          <a:effectRef idx="0">
+            <a:schemeClr val="accent1"/>
+          </a:effectRef>
+          <a:fontRef idx="minor">
+            <a:schemeClr val="tx1"/>
+          </a:fontRef>
+        </p:style>
+      </p:cxnSp>
+      <p:sp>
+        <p:nvSpPr>
+          <p:cNvPr id="82" name="文本框 81"/>
+          <p:cNvSpPr txBox="1"/>
+          <p:nvPr/>
+        </p:nvSpPr>
+        <p:spPr>
+          <a:xfrm>
+            <a:off x="8200599" y="2749346"/>
+            <a:ext cx="1157689" cy="369332"/>
+          </a:xfrm>
+          <a:prstGeom prst="rect">
+            <a:avLst/>
+          </a:prstGeom>
+          <a:noFill/>
+        </p:spPr>
+        <p:txBody>
+          <a:bodyPr wrap="none" rtlCol="0">
+            <a:spAutoFit/>
+          </a:bodyPr>
+          <a:lstStyle/>
+          <a:p>
+            <a:r>
+              <a:rPr lang="en-US" altLang="zh-CN" dirty="0" smtClean="0"/>
+              <a:t>Policy NN</a:t>
+            </a:r>
+            <a:endParaRPr lang="zh-CN" altLang="en-US" dirty="0"/>
+          </a:p>
+        </p:txBody>
+      </p:sp>
+      <p:cxnSp>
+        <p:nvCxnSpPr>
+          <p:cNvPr id="83" name="直接箭头连接符 82"/>
+          <p:cNvCxnSpPr>
+            <a:stCxn id="71" idx="3"/>
+          </p:cNvCxnSpPr>
+          <p:nvPr/>
+        </p:nvCxnSpPr>
+        <p:spPr>
+          <a:xfrm flipV="1">
+            <a:off x="9487939" y="2922795"/>
+            <a:ext cx="814987" cy="11218"/>
+          </a:xfrm>
+          <a:prstGeom prst="straightConnector1">
+            <a:avLst/>
+          </a:prstGeom>
+          <a:ln>
+            <a:tailEnd type="triangle"/>
+          </a:ln>
+        </p:spPr>
+        <p:style>
+          <a:lnRef idx="1">
+            <a:schemeClr val="accent1"/>
+          </a:lnRef>
+          <a:fillRef idx="0">
+            <a:schemeClr val="accent1"/>
+          </a:fillRef>
+          <a:effectRef idx="0">
+            <a:schemeClr val="accent1"/>
+          </a:effectRef>
+          <a:fontRef idx="minor">
+            <a:schemeClr val="tx1"/>
+          </a:fontRef>
+        </p:style>
+      </p:cxnSp>
+      <p:sp>
+        <p:nvSpPr>
+          <p:cNvPr id="85" name="文本框 84"/>
+          <p:cNvSpPr txBox="1"/>
+          <p:nvPr/>
+        </p:nvSpPr>
+        <p:spPr>
+          <a:xfrm>
+            <a:off x="9518862" y="2548153"/>
+            <a:ext cx="1220206" cy="369332"/>
+          </a:xfrm>
+          <a:prstGeom prst="rect">
+            <a:avLst/>
+          </a:prstGeom>
+          <a:noFill/>
+        </p:spPr>
+        <p:txBody>
+          <a:bodyPr wrap="none" rtlCol="0">
+            <a:spAutoFit/>
+          </a:bodyPr>
+          <a:lstStyle/>
+          <a:p>
+            <a:r>
+              <a:rPr lang="en-US" altLang="zh-CN" dirty="0" smtClean="0"/>
+              <a:t>placement</a:t>
+            </a:r>
+            <a:endParaRPr lang="zh-CN" altLang="en-US" dirty="0"/>
+          </a:p>
+        </p:txBody>
+      </p:sp>
+      <p:sp>
+        <p:nvSpPr>
+          <p:cNvPr id="126" name="矩形 125"/>
+          <p:cNvSpPr/>
+          <p:nvPr/>
+        </p:nvSpPr>
+        <p:spPr>
+          <a:xfrm>
+            <a:off x="863629" y="1321120"/>
+            <a:ext cx="1061509" cy="461665"/>
+          </a:xfrm>
+          <a:prstGeom prst="rect">
+            <a:avLst/>
+          </a:prstGeom>
+          <a:noFill/>
+        </p:spPr>
+        <p:txBody>
+          <a:bodyPr wrap="none" lIns="91440" tIns="45720" rIns="91440" bIns="45720">
+            <a:spAutoFit/>
+          </a:bodyPr>
+          <a:lstStyle/>
+          <a:p>
+            <a:pPr algn="ctr"/>
+            <a:r>
+              <a:rPr lang="en-US" altLang="zh-CN" sz="2400" b="0" cap="none" spc="0" dirty="0" smtClean="0">
+                <a:ln w="0"/>
+                <a:solidFill>
+                  <a:schemeClr val="tx1"/>
+                </a:solidFill>
+                <a:effectLst>
+                  <a:outerShdw blurRad="38100" dist="19050" dir="2700000" algn="tl" rotWithShape="0">
+                    <a:schemeClr val="dk1">
+                      <a:alpha val="40000"/>
+                    </a:schemeClr>
+                  </a:outerShdw>
+                </a:effectLst>
+              </a:rPr>
+              <a:t>State s</a:t>
+            </a:r>
+            <a:endParaRPr lang="zh-CN" altLang="en-US" sz="2400" b="0" cap="none" spc="0" dirty="0">
+              <a:ln w="0"/>
+              <a:solidFill>
+                <a:schemeClr val="tx1"/>
+              </a:solidFill>
+              <a:effectLst>
+                <a:outerShdw blurRad="38100" dist="19050" dir="2700000" algn="tl" rotWithShape="0">
+                  <a:schemeClr val="dk1">
+                    <a:alpha val="40000"/>
+                  </a:schemeClr>
+                </a:outerShdw>
+              </a:effectLst>
+            </a:endParaRPr>
+          </a:p>
+        </p:txBody>
+      </p:sp>
+      <p:sp>
+        <p:nvSpPr>
+          <p:cNvPr id="127" name="矩形 126"/>
+          <p:cNvSpPr/>
+          <p:nvPr/>
+        </p:nvSpPr>
+        <p:spPr>
+          <a:xfrm>
+            <a:off x="6263346" y="1339787"/>
+            <a:ext cx="1061509" cy="461665"/>
+          </a:xfrm>
+          <a:prstGeom prst="rect">
+            <a:avLst/>
+          </a:prstGeom>
+          <a:noFill/>
+        </p:spPr>
+        <p:txBody>
+          <a:bodyPr wrap="none" lIns="91440" tIns="45720" rIns="91440" bIns="45720">
+            <a:spAutoFit/>
+          </a:bodyPr>
+          <a:lstStyle/>
+          <a:p>
+            <a:pPr algn="ctr"/>
+            <a:r>
+              <a:rPr lang="en-US" altLang="zh-CN" sz="2400" b="0" cap="none" spc="0" dirty="0" smtClean="0">
+                <a:ln w="0"/>
+                <a:solidFill>
+                  <a:schemeClr val="tx1"/>
+                </a:solidFill>
+                <a:effectLst>
+                  <a:outerShdw blurRad="38100" dist="19050" dir="2700000" algn="tl" rotWithShape="0">
+                    <a:schemeClr val="dk1">
+                      <a:alpha val="40000"/>
+                    </a:schemeClr>
+                  </a:outerShdw>
+                </a:effectLst>
+              </a:rPr>
+              <a:t>State s</a:t>
+            </a:r>
+            <a:endParaRPr lang="zh-CN" altLang="en-US" sz="2400" b="0" cap="none" spc="0" dirty="0">
+              <a:ln w="0"/>
+              <a:solidFill>
+                <a:schemeClr val="tx1"/>
+              </a:solidFill>
+              <a:effectLst>
+                <a:outerShdw blurRad="38100" dist="19050" dir="2700000" algn="tl" rotWithShape="0">
+                  <a:schemeClr val="dk1">
+                    <a:alpha val="40000"/>
+                  </a:schemeClr>
+                </a:outerShdw>
+              </a:effectLst>
+            </a:endParaRPr>
+          </a:p>
+        </p:txBody>
+      </p:sp>
+      <p:sp>
+        <p:nvSpPr>
+          <p:cNvPr id="128" name="文本框 127"/>
+          <p:cNvSpPr txBox="1"/>
+          <p:nvPr/>
+        </p:nvSpPr>
+        <p:spPr>
+          <a:xfrm>
+            <a:off x="36226" y="1384889"/>
+            <a:ext cx="609744" cy="369332"/>
+          </a:xfrm>
+          <a:prstGeom prst="rect">
+            <a:avLst/>
+          </a:prstGeom>
+          <a:noFill/>
+        </p:spPr>
+        <p:txBody>
+          <a:bodyPr wrap="square" rtlCol="0">
+            <a:spAutoFit/>
+          </a:bodyPr>
+          <a:lstStyle/>
+          <a:p>
+            <a:r>
+              <a:rPr lang="en-US" altLang="zh-CN" dirty="0" err="1" smtClean="0"/>
+              <a:t>api</a:t>
+            </a:r>
+            <a:endParaRPr lang="zh-CN" altLang="en-US" dirty="0"/>
+          </a:p>
+        </p:txBody>
+      </p:sp>
+      <p:cxnSp>
+        <p:nvCxnSpPr>
+          <p:cNvPr id="133" name="曲线连接符 132"/>
+          <p:cNvCxnSpPr>
+            <a:stCxn id="128" idx="2"/>
+            <a:endCxn id="13" idx="1"/>
+          </p:cNvCxnSpPr>
+          <p:nvPr/>
+        </p:nvCxnSpPr>
+        <p:spPr>
+          <a:xfrm rot="16200000" flipH="1">
+            <a:off x="168387" y="1926931"/>
+            <a:ext cx="709975" cy="364553"/>
+          </a:xfrm>
+          <a:prstGeom prst="curvedConnector2">
+            <a:avLst/>
+          </a:prstGeom>
+          <a:ln>
+            <a:tailEnd type="triangle"/>
+          </a:ln>
+        </p:spPr>
+        <p:style>
+          <a:lnRef idx="1">
+            <a:schemeClr val="accent1"/>
+          </a:lnRef>
+          <a:fillRef idx="0">
+            <a:schemeClr val="accent1"/>
+          </a:fillRef>
+          <a:effectRef idx="0">
+            <a:schemeClr val="accent1"/>
+          </a:effectRef>
+          <a:fontRef idx="minor">
+            <a:schemeClr val="tx1"/>
+          </a:fontRef>
+        </p:style>
+      </p:cxnSp>
+      <p:sp>
+        <p:nvSpPr>
+          <p:cNvPr id="147" name="文本框 146"/>
+          <p:cNvSpPr txBox="1"/>
+          <p:nvPr/>
+        </p:nvSpPr>
+        <p:spPr>
+          <a:xfrm>
+            <a:off x="5071884" y="847970"/>
+            <a:ext cx="1219487" cy="369332"/>
+          </a:xfrm>
+          <a:prstGeom prst="rect">
+            <a:avLst/>
+          </a:prstGeom>
+          <a:noFill/>
+        </p:spPr>
+        <p:txBody>
+          <a:bodyPr wrap="square" rtlCol="0">
+            <a:spAutoFit/>
+          </a:bodyPr>
+          <a:lstStyle/>
+          <a:p>
+            <a:r>
+              <a:rPr lang="en-US" altLang="zh-CN" dirty="0" smtClean="0"/>
+              <a:t>Job owner</a:t>
+            </a:r>
+            <a:endParaRPr lang="zh-CN" altLang="en-US" dirty="0"/>
+          </a:p>
+        </p:txBody>
+      </p:sp>
+      <p:cxnSp>
+        <p:nvCxnSpPr>
+          <p:cNvPr id="148" name="曲线连接符 147"/>
+          <p:cNvCxnSpPr>
+            <a:stCxn id="147" idx="2"/>
+            <a:endCxn id="74" idx="1"/>
+          </p:cNvCxnSpPr>
+          <p:nvPr/>
+        </p:nvCxnSpPr>
+        <p:spPr>
+          <a:xfrm rot="16200000" flipH="1">
+            <a:off x="5264676" y="1634253"/>
+            <a:ext cx="1247948" cy="414045"/>
+          </a:xfrm>
+          <a:prstGeom prst="curvedConnector2">
+            <a:avLst/>
+          </a:prstGeom>
+          <a:ln>
+            <a:tailEnd type="triangle"/>
+          </a:ln>
+        </p:spPr>
+        <p:style>
+          <a:lnRef idx="1">
+            <a:schemeClr val="accent1"/>
+          </a:lnRef>
+          <a:fillRef idx="0">
+            <a:schemeClr val="accent1"/>
+          </a:fillRef>
+          <a:effectRef idx="0">
+            <a:schemeClr val="accent1"/>
+          </a:effectRef>
+          <a:fontRef idx="minor">
+            <a:schemeClr val="tx1"/>
+          </a:fontRef>
+        </p:style>
+      </p:cxnSp>
+      <p:sp>
+        <p:nvSpPr>
+          <p:cNvPr id="149" name="文本框 148"/>
+          <p:cNvSpPr txBox="1"/>
+          <p:nvPr/>
+        </p:nvSpPr>
+        <p:spPr>
+          <a:xfrm>
+            <a:off x="5372455" y="5593994"/>
+            <a:ext cx="618347" cy="369332"/>
+          </a:xfrm>
+          <a:prstGeom prst="rect">
+            <a:avLst/>
+          </a:prstGeom>
+          <a:noFill/>
+        </p:spPr>
+        <p:txBody>
+          <a:bodyPr wrap="square" rtlCol="0">
+            <a:spAutoFit/>
+          </a:bodyPr>
+          <a:lstStyle/>
+          <a:p>
+            <a:r>
+              <a:rPr lang="en-US" altLang="zh-CN" dirty="0" err="1" smtClean="0"/>
+              <a:t>api</a:t>
+            </a:r>
+            <a:endParaRPr lang="zh-CN" altLang="en-US" dirty="0"/>
+          </a:p>
+        </p:txBody>
+      </p:sp>
+      <p:cxnSp>
+        <p:nvCxnSpPr>
+          <p:cNvPr id="151" name="曲线连接符 150"/>
+          <p:cNvCxnSpPr>
+            <a:stCxn id="149" idx="0"/>
+            <a:endCxn id="75" idx="1"/>
+          </p:cNvCxnSpPr>
+          <p:nvPr/>
+        </p:nvCxnSpPr>
+        <p:spPr>
+          <a:xfrm rot="5400000" flipH="1" flipV="1">
+            <a:off x="4924402" y="4389049"/>
+            <a:ext cx="1962173" cy="447718"/>
+          </a:xfrm>
+          <a:prstGeom prst="curvedConnector2">
+            <a:avLst/>
+          </a:prstGeom>
+          <a:ln>
+            <a:tailEnd type="triangle"/>
+          </a:ln>
+        </p:spPr>
+        <p:style>
+          <a:lnRef idx="1">
+            <a:schemeClr val="accent1"/>
+          </a:lnRef>
+          <a:fillRef idx="0">
+            <a:schemeClr val="accent1"/>
+          </a:fillRef>
+          <a:effectRef idx="0">
+            <a:schemeClr val="accent1"/>
+          </a:effectRef>
+          <a:fontRef idx="minor">
+            <a:schemeClr val="tx1"/>
+          </a:fontRef>
+        </p:style>
+      </p:cxnSp>
+      <p:cxnSp>
+        <p:nvCxnSpPr>
+          <p:cNvPr id="162" name="曲线连接符 161"/>
+          <p:cNvCxnSpPr>
+            <a:stCxn id="149" idx="0"/>
+            <a:endCxn id="76" idx="1"/>
+          </p:cNvCxnSpPr>
+          <p:nvPr/>
+        </p:nvCxnSpPr>
+        <p:spPr>
+          <a:xfrm rot="5400000" flipH="1" flipV="1">
+            <a:off x="5258229" y="4756550"/>
+            <a:ext cx="1260844" cy="414044"/>
+          </a:xfrm>
+          <a:prstGeom prst="curvedConnector2">
+            <a:avLst/>
+          </a:prstGeom>
+          <a:ln>
+            <a:tailEnd type="triangle"/>
+          </a:ln>
+        </p:spPr>
+        <p:style>
+          <a:lnRef idx="1">
+            <a:schemeClr val="accent1"/>
+          </a:lnRef>
+          <a:fillRef idx="0">
+            <a:schemeClr val="accent1"/>
+          </a:fillRef>
+          <a:effectRef idx="0">
+            <a:schemeClr val="accent1"/>
+          </a:effectRef>
+          <a:fontRef idx="minor">
+            <a:schemeClr val="tx1"/>
+          </a:fontRef>
+        </p:style>
+      </p:cxnSp>
+      <p:cxnSp>
+        <p:nvCxnSpPr>
+          <p:cNvPr id="179" name="曲线连接符 178"/>
+          <p:cNvCxnSpPr>
+            <a:stCxn id="128" idx="2"/>
+            <a:endCxn id="15" idx="1"/>
+          </p:cNvCxnSpPr>
+          <p:nvPr/>
+        </p:nvCxnSpPr>
+        <p:spPr>
+          <a:xfrm rot="16200000" flipH="1">
+            <a:off x="-765563" y="2860882"/>
+            <a:ext cx="2577875" cy="364552"/>
+          </a:xfrm>
+          <a:prstGeom prst="curvedConnector2">
+            <a:avLst/>
+          </a:prstGeom>
+          <a:ln>
+            <a:tailEnd type="triangle"/>
+          </a:ln>
+        </p:spPr>
+        <p:style>
+          <a:lnRef idx="1">
+            <a:schemeClr val="accent1"/>
+          </a:lnRef>
+          <a:fillRef idx="0">
+            <a:schemeClr val="accent1"/>
+          </a:fillRef>
+          <a:effectRef idx="0">
+            <a:schemeClr val="accent1"/>
+          </a:effectRef>
+          <a:fontRef idx="minor">
+            <a:schemeClr val="tx1"/>
+          </a:fontRef>
+        </p:style>
+      </p:cxnSp>
+    </p:spTree>
+    <p:extLst>
+      <p:ext uri="{BB962C8B-B14F-4D97-AF65-F5344CB8AC3E}">
+        <p14:creationId xmlns:p14="http://schemas.microsoft.com/office/powerpoint/2010/main" val="3305692693"/>
+      </p:ext>
+    </p:extLst>
+  </p:cSld>
+  <p:clrMapOvr>
+    <a:masterClrMapping/>
+  </p:clrMapOvr>
+</p:sld>
+</file>
+
+<file path=ppt/slides/slide6.xml><?xml version="1.0" encoding="utf-8"?>
+<p:sld xmlns:a="http://schemas.openxmlformats.org/drawingml/2006/main" xmlns:r="http://schemas.openxmlformats.org/officeDocument/2006/relationships" xmlns:p="http://schemas.openxmlformats.org/presentationml/2006/main">
+  <p:cSld>
+    <p:spTree>
+      <p:nvGrpSpPr>
+        <p:cNvPr id="1" name=""/>
+        <p:cNvGrpSpPr/>
+        <p:nvPr/>
+      </p:nvGrpSpPr>
+      <p:grpSpPr>
+        <a:xfrm>
+          <a:off x="0" y="0"/>
+          <a:ext cx="0" cy="0"/>
+          <a:chOff x="0" y="0"/>
+          <a:chExt cx="0" cy="0"/>
+        </a:xfrm>
+      </p:grpSpPr>
+      <p:sp>
+        <p:nvSpPr>
+          <p:cNvPr id="2" name="标题 1"/>
+          <p:cNvSpPr>
+            <a:spLocks noGrp="1"/>
+          </p:cNvSpPr>
+          <p:nvPr>
+            <p:ph type="title"/>
+          </p:nvPr>
+        </p:nvSpPr>
+        <p:spPr/>
+        <p:txBody>
+          <a:bodyPr/>
+          <a:lstStyle/>
+          <a:p>
+            <a:r>
               <a:rPr lang="zh-CN" altLang="en-US" dirty="0" smtClean="0"/>
               <a:t>问老师的问题</a:t>
             </a:r>
@@ -15917,9 +18220,182 @@
               <a:t>来训练</a:t>
             </a:r>
             <a:r>
-              <a:rPr lang="en-US" altLang="zh-CN" smtClean="0"/>
+              <a:rPr lang="en-US" altLang="zh-CN" dirty="0" smtClean="0"/>
               <a:t>?</a:t>
             </a:r>
+            <a:r>
+              <a:rPr lang="zh-CN" altLang="en-US" dirty="0" smtClean="0"/>
+              <a:t>我不确定她是否还在用</a:t>
+            </a:r>
+            <a:endParaRPr lang="en-US" altLang="zh-CN" dirty="0" smtClean="0"/>
+          </a:p>
+          <a:p>
+            <a:pPr lvl="0"/>
+            <a:r>
+              <a:rPr lang="en-US" altLang="zh-CN" dirty="0"/>
+              <a:t>DL2</a:t>
+            </a:r>
+            <a:r>
+              <a:rPr lang="zh-CN" altLang="en-US" dirty="0"/>
+              <a:t>只有</a:t>
+            </a:r>
+            <a:r>
+              <a:rPr lang="en-US" altLang="zh-CN" dirty="0"/>
+              <a:t>worker</a:t>
+            </a:r>
+            <a:r>
+              <a:rPr lang="zh-CN" altLang="en-US" dirty="0"/>
+              <a:t>的输出</a:t>
+            </a:r>
+            <a:r>
+              <a:rPr lang="en-US" altLang="zh-CN" dirty="0"/>
+              <a:t>, </a:t>
+            </a:r>
+            <a:r>
+              <a:rPr lang="zh-CN" altLang="en-US" dirty="0"/>
+              <a:t>没有</a:t>
+            </a:r>
+            <a:r>
+              <a:rPr lang="en-US" altLang="zh-CN" dirty="0"/>
+              <a:t>resource demand</a:t>
+            </a:r>
+            <a:r>
+              <a:rPr lang="zh-CN" altLang="en-US" dirty="0"/>
+              <a:t>比如</a:t>
+            </a:r>
+            <a:r>
+              <a:rPr lang="en-US" altLang="zh-CN" dirty="0"/>
+              <a:t>CPU,GPU</a:t>
+            </a:r>
+            <a:r>
+              <a:rPr lang="zh-CN" altLang="en-US" dirty="0"/>
+              <a:t>的输出</a:t>
+            </a:r>
+            <a:r>
+              <a:rPr lang="en-US" altLang="zh-CN" dirty="0"/>
+              <a:t>, </a:t>
+            </a:r>
+            <a:r>
+              <a:rPr lang="zh-CN" altLang="en-US" dirty="0"/>
+              <a:t>在哪里有相关</a:t>
+            </a:r>
+            <a:r>
+              <a:rPr lang="zh-CN" altLang="en-US" dirty="0" smtClean="0"/>
+              <a:t>文献分配</a:t>
+            </a:r>
+            <a:r>
+              <a:rPr lang="en-US" altLang="zh-CN" dirty="0" smtClean="0"/>
+              <a:t>CPU</a:t>
+            </a:r>
+            <a:r>
+              <a:rPr lang="zh-CN" altLang="en-US" dirty="0" smtClean="0"/>
+              <a:t>的</a:t>
+            </a:r>
+            <a:r>
+              <a:rPr lang="en-US" altLang="zh-CN" dirty="0" smtClean="0"/>
+              <a:t>??(job owner</a:t>
+            </a:r>
+            <a:r>
+              <a:rPr lang="zh-CN" altLang="en-US" dirty="0" smtClean="0"/>
+              <a:t>提交</a:t>
+            </a:r>
+            <a:r>
+              <a:rPr lang="en-US" altLang="zh-CN" dirty="0" smtClean="0"/>
+              <a:t>demand)</a:t>
+            </a:r>
+          </a:p>
+          <a:p>
+            <a:pPr lvl="0"/>
+            <a:r>
+              <a:rPr lang="en-US" altLang="zh-CN" dirty="0" smtClean="0"/>
+              <a:t>Harmony</a:t>
+            </a:r>
+            <a:r>
+              <a:rPr lang="zh-CN" altLang="en-US" dirty="0" smtClean="0"/>
+              <a:t>的论文</a:t>
+            </a:r>
+            <a:r>
+              <a:rPr lang="en-US" altLang="zh-CN" dirty="0" smtClean="0"/>
+              <a:t>,</a:t>
+            </a:r>
+            <a:r>
+              <a:rPr lang="en-US" altLang="zh-CN" dirty="0"/>
+              <a:t>w (p), </a:t>
+            </a:r>
+            <a:r>
+              <a:rPr lang="zh-CN" altLang="en-US" dirty="0"/>
+              <a:t>记录</a:t>
+            </a:r>
+            <a:r>
+              <a:rPr lang="en-US" altLang="zh-CN" dirty="0" smtClean="0"/>
+              <a:t>PS</a:t>
+            </a:r>
+            <a:r>
+              <a:rPr lang="zh-CN" altLang="en-US" dirty="0" smtClean="0"/>
+              <a:t>数量</a:t>
+            </a:r>
+            <a:r>
+              <a:rPr lang="en-US" altLang="zh-CN" dirty="0" smtClean="0"/>
+              <a:t>. </a:t>
+            </a:r>
+            <a:r>
+              <a:rPr lang="zh-CN" altLang="en-US" dirty="0" smtClean="0"/>
+              <a:t>这个不是和上面的</a:t>
+            </a:r>
+            <a:r>
+              <a:rPr lang="en-US" altLang="zh-CN" dirty="0" err="1" smtClean="0"/>
+              <a:t>rn</a:t>
+            </a:r>
+            <a:r>
+              <a:rPr lang="zh-CN" altLang="en-US" dirty="0" smtClean="0"/>
+              <a:t>重复了吗</a:t>
+            </a:r>
+            <a:r>
+              <a:rPr lang="en-US" altLang="zh-CN" dirty="0" smtClean="0"/>
+              <a:t>?</a:t>
+            </a:r>
+          </a:p>
+          <a:p>
+            <a:pPr lvl="0"/>
+            <a:r>
+              <a:rPr lang="en-US" altLang="zh-CN" dirty="0"/>
+              <a:t>Harmony</a:t>
+            </a:r>
+            <a:r>
+              <a:rPr lang="zh-CN" altLang="en-US" dirty="0"/>
+              <a:t>的论文</a:t>
+            </a:r>
+            <a:r>
+              <a:rPr lang="en-US" altLang="zh-CN" dirty="0" smtClean="0"/>
+              <a:t>,d </a:t>
+            </a:r>
+            <a:r>
+              <a:rPr lang="zh-CN" altLang="en-US" dirty="0" smtClean="0"/>
+              <a:t>矩阵是不是就是目前存在的</a:t>
+            </a:r>
+            <a:r>
+              <a:rPr lang="en-US" altLang="zh-CN" dirty="0" smtClean="0"/>
+              <a:t>job</a:t>
+            </a:r>
+            <a:r>
+              <a:rPr lang="zh-CN" altLang="en-US" dirty="0" smtClean="0"/>
+              <a:t>的运行情况</a:t>
+            </a:r>
+            <a:r>
+              <a:rPr lang="en-US" altLang="zh-CN" dirty="0" smtClean="0"/>
+              <a:t>, </a:t>
+            </a:r>
+            <a:r>
+              <a:rPr lang="zh-CN" altLang="en-US" dirty="0" smtClean="0"/>
+              <a:t>不包括新提交的</a:t>
+            </a:r>
+            <a:r>
+              <a:rPr lang="en-US" altLang="zh-CN" dirty="0" smtClean="0"/>
+              <a:t>job?</a:t>
+            </a:r>
+          </a:p>
+          <a:p>
+            <a:pPr lvl="0"/>
             <a:endParaRPr lang="zh-CN" altLang="en-US" dirty="0"/>
           </a:p>
         </p:txBody>
@@ -15937,7 +18413,124 @@
 </p:sld>
 </file>
 
-<file path=ppt/slides/slide4.xml><?xml version="1.0" encoding="utf-8"?>
+<file path=ppt/slides/slide7.xml><?xml version="1.0" encoding="utf-8"?>
+<p:sld xmlns:a="http://schemas.openxmlformats.org/drawingml/2006/main" xmlns:r="http://schemas.openxmlformats.org/officeDocument/2006/relationships" xmlns:p="http://schemas.openxmlformats.org/presentationml/2006/main">
+  <p:cSld>
+    <p:spTree>
+      <p:nvGrpSpPr>
+        <p:cNvPr id="1" name=""/>
+        <p:cNvGrpSpPr/>
+        <p:nvPr/>
+      </p:nvGrpSpPr>
+      <p:grpSpPr>
+        <a:xfrm>
+          <a:off x="0" y="0"/>
+          <a:ext cx="0" cy="0"/>
+          <a:chOff x="0" y="0"/>
+          <a:chExt cx="0" cy="0"/>
+        </a:xfrm>
+      </p:grpSpPr>
+      <p:sp>
+        <p:nvSpPr>
+          <p:cNvPr id="2" name="标题 1"/>
+          <p:cNvSpPr>
+            <a:spLocks noGrp="1"/>
+          </p:cNvSpPr>
+          <p:nvPr>
+            <p:ph type="title"/>
+          </p:nvPr>
+        </p:nvSpPr>
+        <p:spPr/>
+        <p:txBody>
+          <a:bodyPr/>
+          <a:lstStyle/>
+          <a:p>
+            <a:r>
+              <a:rPr lang="zh-CN" altLang="en-US" dirty="0" smtClean="0"/>
+              <a:t>问老师的问题</a:t>
+            </a:r>
+            <a:endParaRPr lang="zh-CN" altLang="en-US" dirty="0"/>
+          </a:p>
+        </p:txBody>
+      </p:sp>
+      <p:sp>
+        <p:nvSpPr>
+          <p:cNvPr id="3" name="内容占位符 2"/>
+          <p:cNvSpPr>
+            <a:spLocks noGrp="1"/>
+          </p:cNvSpPr>
+          <p:nvPr>
+            <p:ph idx="1"/>
+          </p:nvPr>
+        </p:nvSpPr>
+        <p:spPr/>
+        <p:txBody>
+          <a:bodyPr/>
+          <a:lstStyle/>
+          <a:p>
+            <a:pPr lvl="0"/>
+            <a:r>
+              <a:rPr lang="en-US" altLang="zh-CN" dirty="0" smtClean="0"/>
+              <a:t>Harmony</a:t>
+            </a:r>
+            <a:r>
+              <a:rPr lang="zh-CN" altLang="en-US" dirty="0" smtClean="0"/>
+              <a:t>为什么要预测</a:t>
+            </a:r>
+            <a:r>
+              <a:rPr lang="en-US" altLang="zh-CN" dirty="0" smtClean="0"/>
+              <a:t>reward? </a:t>
+            </a:r>
+            <a:r>
+              <a:rPr lang="zh-CN" altLang="en-US" dirty="0" smtClean="0"/>
+              <a:t>为什么他不用实际速度作为</a:t>
+            </a:r>
+            <a:r>
+              <a:rPr lang="en-US" altLang="zh-CN" dirty="0" smtClean="0"/>
+              <a:t>reward.fig6 </a:t>
+            </a:r>
+            <a:r>
+              <a:rPr lang="zh-CN" altLang="en-US" dirty="0" smtClean="0"/>
+              <a:t>因为</a:t>
+            </a:r>
+            <a:r>
+              <a:rPr lang="en-US" altLang="zh-CN" dirty="0" smtClean="0"/>
+              <a:t>online</a:t>
+            </a:r>
+            <a:r>
+              <a:rPr lang="zh-CN" altLang="en-US" dirty="0" smtClean="0"/>
+              <a:t>不够</a:t>
+            </a:r>
+            <a:r>
+              <a:rPr lang="en-US" altLang="zh-CN" dirty="0" smtClean="0"/>
+              <a:t>, </a:t>
+            </a:r>
+            <a:r>
+              <a:rPr lang="zh-CN" altLang="en-US" dirty="0" smtClean="0"/>
+              <a:t>需要线下自学习</a:t>
+            </a:r>
+            <a:r>
+              <a:rPr lang="en-US" altLang="zh-CN" dirty="0" smtClean="0"/>
+              <a:t>.</a:t>
+            </a:r>
+            <a:endParaRPr lang="zh-CN" altLang="en-US" dirty="0"/>
+          </a:p>
+        </p:txBody>
+      </p:sp>
+    </p:spTree>
+    <p:extLst>
+      <p:ext uri="{BB962C8B-B14F-4D97-AF65-F5344CB8AC3E}">
+        <p14:creationId xmlns:p14="http://schemas.microsoft.com/office/powerpoint/2010/main" val="1277663186"/>
+      </p:ext>
+    </p:extLst>
+  </p:cSld>
+  <p:clrMapOvr>
+    <a:masterClrMapping/>
+  </p:clrMapOvr>
+</p:sld>
+</file>
+
+<file path=ppt/slides/slide8.xml><?xml version="1.0" encoding="utf-8"?>
 <p:sld xmlns:a="http://schemas.openxmlformats.org/drawingml/2006/main" xmlns:r="http://schemas.openxmlformats.org/officeDocument/2006/relationships" xmlns:p="http://schemas.openxmlformats.org/presentationml/2006/main">
   <p:cSld>
     <p:spTree>

</xml_diff>